<commit_message>
Update the pitch deck with cloud backup and the in-app facilitator view
- New slide "Your progress follows you to any phone": automatic backup
  (claude.ai account or mobile + PIN), privacy, offline
- Facilitator slide shows the new in-app facilitator view
- "How it is built" now shows the two ways to sync: hosted on claude.ai
  with the built-in database, or the Node + SQLite server
- App size updated to 239 KB; deck is now 14 slides

Co-Authored-By: Claude Opus 5.5 <noreply@anthropic.com>
Claude-Session: https://claude.ai/code/session_017mVkYdAtUcUqUrgRiSXn8W
</commit_message>
<xml_diff>
--- a/pitch/Pehla Kadam - pitch.pptx
+++ b/pitch/Pehla Kadam - pitch.pptx
@@ -18,9 +18,10 @@
     <p:sldId id="266" r:id="rId12"/>
     <p:sldId id="267" r:id="rId13"/>
     <p:sldId id="268" r:id="rId14"/>
+    <p:sldId id="269" r:id="rId15"/>
   </p:sldIdLst>
   <p:notesMasterIdLst>
-    <p:notesMasterId r:id="rId15"/>
+    <p:notesMasterId r:id="rId16"/>
   </p:notesMasterIdLst>
   <p:sldSz cx="12192000" cy="6858000"/>
   <p:notesSz cx="6858000" cy="12192000"/>
@@ -119,33 +120,34 @@
   <p:extLst>
     <p:ext uri="{521415D9-36F7-43E2-AB2F-B90AF26B5E84}">
       <p14:sectionLst xmlns:p14="http://schemas.microsoft.com/office/powerpoint/2010/main">
-        <p14:section name="Why" id="{25b497d7-4153-05dc-d0ed-5a79527f4e4b}">
+        <p14:section name="Why" id="{49f9bdd5-7a51-d699-0243-82d0526d0fb4}">
           <p14:sldIdLst>
             <p14:sldId id="256"/>
             <p14:sldId id="257"/>
             <p14:sldId id="258"/>
           </p14:sldIdLst>
         </p14:section>
-        <p14:section name="The idea" id="{24e76698-ef08-45a1-b2bd-ae4ea0aa2bd6}">
+        <p14:section name="The idea" id="{e4aaf83a-6ef7-512c-8299-7ef7b484a8e8}">
           <p14:sldIdLst>
             <p14:sldId id="259"/>
             <p14:sldId id="260"/>
             <p14:sldId id="261"/>
           </p14:sldIdLst>
         </p14:section>
-        <p14:section name="The product" id="{646ad27d-7b4c-b339-ee77-a815685565ed}">
+        <p14:section name="The product" id="{effc4795-b051-8af6-02db-eb3e30912d47}">
           <p14:sldIdLst>
             <p14:sldId id="262"/>
             <p14:sldId id="263"/>
             <p14:sldId id="264"/>
             <p14:sldId id="265"/>
+            <p14:sldId id="266"/>
           </p14:sldIdLst>
         </p14:section>
-        <p14:section name="Build and next steps" id="{5455bb0c-e667-0dcd-f9d8-8db94533b130}">
+        <p14:section name="Build and next steps" id="{75445ae2-16d9-cfd4-9d76-4b88c5015ca9}">
           <p14:sldIdLst>
-            <p14:sldId id="266"/>
             <p14:sldId id="267"/>
             <p14:sldId id="268"/>
+            <p14:sldId id="269"/>
           </p14:sldIdLst>
         </p14:section>
       </p14:sectionLst>
@@ -640,7 +642,7 @@
           <a:p>
             <a:r>
               <a:rPr lang="en-US" dirty="0"/>
-              <a:t>Learning sticks better in groups. A self-help-group leader or NGO trainer creates a group and shares its code; learners join from their own phone. The facilitator then sees who has opened an account, who is stuck at which step, who has not added a nominee, and which scam messages still fool the group. Across all learners, an anonymous insights page tells CDSL which concepts confuse new investors most. These screens use our seeded demo group.</a:t>
+              <a:t>A practice account is only useful if it is still there tomorrow. On the hosted claude.ai page, progress saves to the learner’s own claude.ai account automatically, with no PIN to remember, and comes back on any device. On our own server, learners back up with their mobile number and a PIN. Either way, personal details like PAN, Aadhaar and mobile, and every trade, stay in the learner’s private space; facilitators only ever see names and progress. And with no network, the app keeps working on the phone.</a:t>
             </a:r>
             <a:endParaRPr lang="en-US" dirty="0"/>
           </a:p>
@@ -728,7 +730,7 @@
           <a:p>
             <a:r>
               <a:rPr lang="en-US" dirty="0"/>
-              <a:t>The learner app is a single 218-kilobyte HTML file. It needs no network, no sign-up and no app store, so it runs on a basic phone. When it is served by our Node.js and SQLite server, learners can back up and restore across phones. The server never trusts the phone: it replays every trade against the same simulated price engine and refuses anything that does not add up, then writes a proper depository ledger: demat accounts, holdings, transactions, the T+1 settlement queue and corporate-action entitlements. Twenty-four automated tests cover it, and it deploys on Render’s free plan.</a:t>
+              <a:t>Learning sticks better in groups. A self-help-group leader or NGO trainer opens the facilitator view inside the app, creates a group and shares its six-letter code; learners join from their own phone. The facilitator sees who has opened an account, who is stuck at which step, who has not added a nominee, and which scam messages still fool the group. On the hosted page, anyone the owner shares it with as an editor becomes a facilitator. Across all learners, an anonymous insights page tells CDSL which concepts confuse new investors most. This screen uses our seeded demo group.</a:t>
             </a:r>
             <a:endParaRPr lang="en-US" dirty="0"/>
           </a:p>
@@ -816,7 +818,7 @@
           <a:p>
             <a:r>
               <a:rPr lang="en-US" dirty="0"/>
-              <a:t>Our proposed next steps. First, a pilot with a few depository participants and self-help-group networks, measuring confidence with a short quiz before and after. Second, more languages; every string already lives in one translation object, so adding Marathi or Tamil is translation work, not engineering. Third, a bridge to the real thing: when a learner is ready, a guided hand-off to opening an actual demat account with a DP, using the same alert and statement formats they practised with. The bracketed items are ours to fill in with CDSL.</a:t>
+              <a:t>The learner app is a single 239-kilobyte HTML file. It needs no network, no sign-up and no app store, so it runs on a basic phone. It can sync two ways. Hosted on claude.ai, it uses the page’s built-in database: backup, groups and insights work with nothing to deploy, for people in our organization. On our own Node.js and SQLite server, which can run on any public URL including Render’s free plan, the server never trusts the phone: it replays every trade against the same simulated price engine and refuses anything that does not add up, then writes a proper depository ledger. Twenty-four automated tests cover the server.</a:t>
             </a:r>
             <a:endParaRPr lang="en-US" dirty="0"/>
           </a:p>
@@ -904,7 +906,7 @@
           <a:p>
             <a:r>
               <a:rPr lang="en-US" dirty="0"/>
-              <a:t>Please try it yourselves: it takes about three minutes. Open an account with demo details, buy some ITC on day one, tap “Next day” and watch the CDSL alert and then the dividend arrive. Open the CAS statement and the dashboard, and try Scam Shield. Pehla Kadam is the first step to becoming an Atmanirbhar investor. Thank you.</a:t>
+              <a:t>Our proposed next steps. First, a pilot with a few depository participants and self-help-group networks, measuring confidence with a short quiz before and after. Second, more languages; every string already lives in one translation object, so adding Marathi or Tamil is translation work, not engineering. Third, a bridge to the real thing: when a learner is ready, a guided hand-off to opening an actual demat account with a DP, using the same alert and statement formats they practised with. The bracketed items are ours to fill in with CDSL.</a:t>
             </a:r>
             <a:endParaRPr lang="en-US" dirty="0"/>
           </a:p>
@@ -928,6 +930,94 @@
             <a:fld id="{F7021451-1387-4CA6-816F-3879F97B5CBC}" type="slidenum">
               <a:rPr lang="en-US"/>
               <a:t>13</a:t>
+            </a:fld>
+            <a:endParaRPr lang="en-US"/>
+          </a:p>
+        </p:txBody>
+      </p:sp>
+    </p:spTree>
+    <p:extLst>
+      <p:ext uri="{BB962C8B-B14F-4D97-AF65-F5344CB8AC3E}">
+        <p14:creationId xmlns:p14="http://schemas.microsoft.com/office/powerpoint/2010/main" val="1024086991"/>
+      </p:ext>
+    </p:extLst>
+  </p:cSld>
+  <p:clrMapOvr>
+    <a:masterClrMapping/>
+  </p:clrMapOvr>
+</p:notes>
+</file>
+
+<file path=ppt/notesSlides/notesSlide14.xml><?xml version="1.0" encoding="utf-8"?>
+<p:notes xmlns:a="http://schemas.openxmlformats.org/drawingml/2006/main" xmlns:r="http://schemas.openxmlformats.org/officeDocument/2006/relationships" xmlns:p="http://schemas.openxmlformats.org/presentationml/2006/main">
+  <p:cSld>
+    <p:spTree>
+      <p:nvGrpSpPr>
+        <p:cNvPr id="1" name=""/>
+        <p:cNvGrpSpPr/>
+        <p:nvPr/>
+      </p:nvGrpSpPr>
+      <p:grpSpPr>
+        <a:xfrm>
+          <a:off x="0" y="0"/>
+          <a:ext cx="0" cy="0"/>
+          <a:chOff x="0" y="0"/>
+          <a:chExt cx="0" cy="0"/>
+        </a:xfrm>
+      </p:grpSpPr>
+      <p:sp>
+        <p:nvSpPr>
+          <p:cNvPr id="2" name="Slide Image Placeholder 1"/>
+          <p:cNvSpPr>
+            <a:spLocks noGrp="1" noRot="1" noChangeAspect="1"/>
+          </p:cNvSpPr>
+          <p:nvPr>
+            <p:ph type="sldImg"/>
+          </p:nvPr>
+        </p:nvSpPr>
+        <p:spPr/>
+      </p:sp>
+      <p:sp>
+        <p:nvSpPr>
+          <p:cNvPr id="3" name="Notes Placeholder 2"/>
+          <p:cNvSpPr>
+            <a:spLocks noGrp="1"/>
+          </p:cNvSpPr>
+          <p:nvPr>
+            <p:ph type="body" idx="1"/>
+          </p:nvPr>
+        </p:nvSpPr>
+        <p:spPr/>
+        <p:txBody>
+          <a:bodyPr/>
+          <a:lstStyle/>
+          <a:p>
+            <a:r>
+              <a:rPr lang="en-US" dirty="0"/>
+              <a:t>Please try it yourselves: it takes about three minutes. Open an account with demo details, buy some ITC on day one, tap “Next day” and watch the CDSL alert and then the dividend arrive. Open the CAS statement and the dashboard, and try Scam Shield. Pehla Kadam is the first step to becoming an Atmanirbhar investor. Thank you.</a:t>
+            </a:r>
+            <a:endParaRPr lang="en-US" dirty="0"/>
+          </a:p>
+        </p:txBody>
+      </p:sp>
+      <p:sp>
+        <p:nvSpPr>
+          <p:cNvPr id="4" name="Slide Number Placeholder 3"/>
+          <p:cNvSpPr>
+            <a:spLocks noGrp="1"/>
+          </p:cNvSpPr>
+          <p:nvPr>
+            <p:ph type="sldNum" sz="quarter" idx="10"/>
+          </p:nvPr>
+        </p:nvSpPr>
+        <p:spPr/>
+        <p:txBody>
+          <a:bodyPr/>
+          <a:lstStyle/>
+          <a:p>
+            <a:fld id="{F7021451-1387-4CA6-816F-3879F97B5CBC}" type="slidenum">
+              <a:rPr lang="en-US"/>
+              <a:t>14</a:t>
             </a:fld>
             <a:endParaRPr lang="en-US"/>
           </a:p>
@@ -3424,9 +3514,8 @@
         </p:nvPicPr>
         <p:blipFill>
           <a:blip r:embed="rId1"/>
-          <a:stretch>
-            <a:fillRect/>
-          </a:stretch>
+          <a:srcRect l="0" r="0" t="0" b="0"/>
+          <a:stretch/>
         </p:blipFill>
         <p:spPr>
           <a:xfrm>
@@ -3492,10 +3581,10 @@
             <a:r>
               <a:rPr lang="en-US" sz="1200" b="1" spc="200" kern="0" dirty="0">
                 <a:solidFill>
-                  <a:schemeClr val="accent4"/>
-                </a:solidFill>
-              </a:rPr>
-              <a:t>BEYOND ONE PHONE</a:t>
+                  <a:schemeClr val="accent1"/>
+                </a:solidFill>
+              </a:rPr>
+              <a:t>CLOUD BACKUP</a:t>
             </a:r>
             <a:endParaRPr lang="en-US" sz="1200" dirty="0"/>
           </a:p>
@@ -3512,7 +3601,7 @@
         <p:spPr>
           <a:xfrm>
             <a:off x="813816" y="1051560"/>
-            <a:ext cx="4572000" cy="2286000"/>
+            <a:ext cx="7863840" cy="1097280"/>
           </a:xfrm>
           <a:prstGeom prst="rect">
             <a:avLst/>
@@ -3530,10 +3619,10 @@
             <a:r>
               <a:rPr lang="en-US" sz="3600" b="1" dirty="0">
                 <a:solidFill>
-                  <a:schemeClr val="bg2"/>
-                </a:solidFill>
-              </a:rPr>
-              <a:t>Facilitators see who is stuck. CDSL sees what confuses people.</a:t>
+                  <a:schemeClr val="tx1"/>
+                </a:solidFill>
+              </a:rPr>
+              <a:t>Your progress follows you to any phone</a:t>
             </a:r>
             <a:endParaRPr lang="en-US" sz="3600" dirty="0"/>
           </a:p>
@@ -3541,50 +3630,23 @@
       </p:sp>
       <p:sp>
         <p:nvSpPr>
-          <p:cNvPr id="4" name="Text 2"/>
-          <p:cNvSpPr txBox="1"/>
-          <p:nvPr/>
-        </p:nvSpPr>
-        <p:spPr>
-          <a:xfrm>
-            <a:off x="813816" y="3566160"/>
-            <a:ext cx="4572000" cy="1097280"/>
-          </a:xfrm>
-          <a:prstGeom prst="rect">
-            <a:avLst/>
-          </a:prstGeom>
-          <a:noFill/>
-          <a:ln/>
-        </p:spPr>
-        <p:txBody>
-          <a:bodyPr wrap="square" lIns="0" tIns="0" rIns="0" bIns="0" rtlCol="0" anchor="t"/>
-          <a:lstStyle/>
-          <a:p>
-            <a:pPr indent="0" marL="0">
-              <a:buNone/>
-            </a:pPr>
-            <a:r>
-              <a:rPr lang="en-US" sz="1600" b="1" dirty="0">
-                <a:solidFill>
-                  <a:schemeClr val="accent2"/>
-                </a:solidFill>
-              </a:rPr>
-              <a:t>SHG leaders and NGO trainers </a:t>
-            </a:r>
-            <a:pPr indent="0" marL="0">
-              <a:buNone/>
-            </a:pPr>
-            <a:r>
-              <a:rPr lang="en-US" sz="1600" dirty="0">
-                <a:solidFill>
-                  <a:schemeClr val="accent6"/>
-                </a:solidFill>
-              </a:rPr>
-              <a:t>create a group, share a 6-letter code and follow each learner’s steps, nominees and scam answers.</a:t>
-            </a:r>
-            <a:endParaRPr lang="en-US" sz="1600" dirty="0"/>
-          </a:p>
-        </p:txBody>
+          <p:cNvPr id="4" name="Saved automatically marker"/>
+          <p:cNvSpPr/>
+          <p:nvPr/>
+        </p:nvSpPr>
+        <p:spPr>
+          <a:xfrm>
+            <a:off x="813816" y="2532888"/>
+            <a:ext cx="384048" cy="384048"/>
+          </a:xfrm>
+          <a:prstGeom prst="ellipse">
+            <a:avLst/>
+          </a:prstGeom>
+          <a:solidFill>
+            <a:schemeClr val="accent1"/>
+          </a:solidFill>
+          <a:ln/>
+        </p:spPr>
       </p:sp>
       <p:sp>
         <p:nvSpPr>
@@ -3594,48 +3656,387 @@
         </p:nvSpPr>
         <p:spPr>
           <a:xfrm>
-            <a:off x="813816" y="4800600"/>
-            <a:ext cx="4572000" cy="914400"/>
-          </a:xfrm>
-          <a:prstGeom prst="rect">
-            <a:avLst/>
-          </a:prstGeom>
-          <a:noFill/>
-          <a:ln/>
-        </p:spPr>
-        <p:txBody>
-          <a:bodyPr wrap="square" lIns="0" tIns="0" rIns="0" bIns="0" rtlCol="0" anchor="t"/>
-          <a:lstStyle/>
-          <a:p>
-            <a:pPr indent="0" marL="0">
-              <a:buNone/>
-            </a:pPr>
-            <a:r>
-              <a:rPr lang="en-US" sz="1600" b="1" dirty="0">
-                <a:solidFill>
-                  <a:schemeClr val="accent2"/>
-                </a:solidFill>
-              </a:rPr>
-              <a:t>Anonymous insights </a:t>
-            </a:r>
-            <a:pPr indent="0" marL="0">
-              <a:buNone/>
-            </a:pPr>
-            <a:r>
-              <a:rPr lang="en-US" sz="1600" dirty="0">
-                <a:solidFill>
-                  <a:schemeClr val="accent6"/>
-                </a:solidFill>
-              </a:rPr>
-              <a:t>show which steps learners skip and which scams still fool them.</a:t>
-            </a:r>
-            <a:endParaRPr lang="en-US" sz="1600" dirty="0"/>
-          </a:p>
-        </p:txBody>
+            <a:off x="813816" y="2578608"/>
+            <a:ext cx="384048" cy="292608"/>
+          </a:xfrm>
+          <a:prstGeom prst="rect">
+            <a:avLst/>
+          </a:prstGeom>
+          <a:noFill/>
+          <a:ln/>
+        </p:spPr>
+        <p:txBody>
+          <a:bodyPr wrap="square" lIns="0" tIns="0" rIns="0" bIns="0" rtlCol="0" anchor="t"/>
+          <a:lstStyle/>
+          <a:p>
+            <a:pPr algn="ctr" indent="0" marL="0">
+              <a:buNone/>
+            </a:pPr>
+            <a:r>
+              <a:rPr lang="en-US" sz="1400" b="1" dirty="0">
+                <a:solidFill>
+                  <a:schemeClr val="bg1"/>
+                </a:solidFill>
+              </a:rPr>
+              <a:t>1</a:t>
+            </a:r>
+            <a:endParaRPr lang="en-US" sz="1400" dirty="0"/>
+          </a:p>
+        </p:txBody>
+      </p:sp>
+      <p:sp>
+        <p:nvSpPr>
+          <p:cNvPr id="6" name="Text 4"/>
+          <p:cNvSpPr txBox="1"/>
+          <p:nvPr/>
+        </p:nvSpPr>
+        <p:spPr>
+          <a:xfrm>
+            <a:off x="1408176" y="2514600"/>
+            <a:ext cx="7223760" cy="384048"/>
+          </a:xfrm>
+          <a:prstGeom prst="rect">
+            <a:avLst/>
+          </a:prstGeom>
+          <a:noFill/>
+          <a:ln/>
+        </p:spPr>
+        <p:txBody>
+          <a:bodyPr wrap="square" lIns="0" tIns="0" rIns="0" bIns="0" rtlCol="0" anchor="t"/>
+          <a:lstStyle/>
+          <a:p>
+            <a:pPr indent="0" marL="0">
+              <a:buNone/>
+            </a:pPr>
+            <a:r>
+              <a:rPr lang="en-US" sz="1800" b="1" dirty="0">
+                <a:solidFill>
+                  <a:schemeClr val="tx1"/>
+                </a:solidFill>
+              </a:rPr>
+              <a:t>Saved automatically</a:t>
+            </a:r>
+            <a:endParaRPr lang="en-US" sz="1800" dirty="0"/>
+          </a:p>
+        </p:txBody>
+      </p:sp>
+      <p:sp>
+        <p:nvSpPr>
+          <p:cNvPr id="7" name="Text 5"/>
+          <p:cNvSpPr txBox="1"/>
+          <p:nvPr/>
+        </p:nvSpPr>
+        <p:spPr>
+          <a:xfrm>
+            <a:off x="1408176" y="2926080"/>
+            <a:ext cx="7223760" cy="777240"/>
+          </a:xfrm>
+          <a:prstGeom prst="rect">
+            <a:avLst/>
+          </a:prstGeom>
+          <a:noFill/>
+          <a:ln/>
+        </p:spPr>
+        <p:txBody>
+          <a:bodyPr wrap="square" lIns="0" tIns="0" rIns="0" bIns="0" rtlCol="0" anchor="t"/>
+          <a:lstStyle/>
+          <a:p>
+            <a:pPr indent="0" marL="0">
+              <a:buNone/>
+            </a:pPr>
+            <a:r>
+              <a:rPr lang="en-US" sz="1400" dirty="0">
+                <a:solidFill>
+                  <a:schemeClr val="tx2"/>
+                </a:solidFill>
+              </a:rPr>
+              <a:t>On the hosted claude.ai page it saves to the learner’s own account with no PIN; on our own server, with mobile number and a PIN.</a:t>
+            </a:r>
+            <a:endParaRPr lang="en-US" sz="1400" dirty="0"/>
+          </a:p>
+        </p:txBody>
+      </p:sp>
+      <p:sp>
+        <p:nvSpPr>
+          <p:cNvPr id="8" name="Private by design marker"/>
+          <p:cNvSpPr/>
+          <p:nvPr/>
+        </p:nvSpPr>
+        <p:spPr>
+          <a:xfrm>
+            <a:off x="813816" y="3675888"/>
+            <a:ext cx="384048" cy="384048"/>
+          </a:xfrm>
+          <a:prstGeom prst="ellipse">
+            <a:avLst/>
+          </a:prstGeom>
+          <a:solidFill>
+            <a:schemeClr val="accent1"/>
+          </a:solidFill>
+          <a:ln/>
+        </p:spPr>
+      </p:sp>
+      <p:sp>
+        <p:nvSpPr>
+          <p:cNvPr id="9" name="Text 7"/>
+          <p:cNvSpPr txBox="1"/>
+          <p:nvPr/>
+        </p:nvSpPr>
+        <p:spPr>
+          <a:xfrm>
+            <a:off x="813816" y="3721608"/>
+            <a:ext cx="384048" cy="292608"/>
+          </a:xfrm>
+          <a:prstGeom prst="rect">
+            <a:avLst/>
+          </a:prstGeom>
+          <a:noFill/>
+          <a:ln/>
+        </p:spPr>
+        <p:txBody>
+          <a:bodyPr wrap="square" lIns="0" tIns="0" rIns="0" bIns="0" rtlCol="0" anchor="t"/>
+          <a:lstStyle/>
+          <a:p>
+            <a:pPr algn="ctr" indent="0" marL="0">
+              <a:buNone/>
+            </a:pPr>
+            <a:r>
+              <a:rPr lang="en-US" sz="1400" b="1" dirty="0">
+                <a:solidFill>
+                  <a:schemeClr val="bg1"/>
+                </a:solidFill>
+              </a:rPr>
+              <a:t>2</a:t>
+            </a:r>
+            <a:endParaRPr lang="en-US" sz="1400" dirty="0"/>
+          </a:p>
+        </p:txBody>
+      </p:sp>
+      <p:sp>
+        <p:nvSpPr>
+          <p:cNvPr id="10" name="Text 8"/>
+          <p:cNvSpPr txBox="1"/>
+          <p:nvPr/>
+        </p:nvSpPr>
+        <p:spPr>
+          <a:xfrm>
+            <a:off x="1408176" y="3657600"/>
+            <a:ext cx="7223760" cy="384048"/>
+          </a:xfrm>
+          <a:prstGeom prst="rect">
+            <a:avLst/>
+          </a:prstGeom>
+          <a:noFill/>
+          <a:ln/>
+        </p:spPr>
+        <p:txBody>
+          <a:bodyPr wrap="square" lIns="0" tIns="0" rIns="0" bIns="0" rtlCol="0" anchor="t"/>
+          <a:lstStyle/>
+          <a:p>
+            <a:pPr indent="0" marL="0">
+              <a:buNone/>
+            </a:pPr>
+            <a:r>
+              <a:rPr lang="en-US" sz="1800" b="1" dirty="0">
+                <a:solidFill>
+                  <a:schemeClr val="tx1"/>
+                </a:solidFill>
+              </a:rPr>
+              <a:t>Private by design</a:t>
+            </a:r>
+            <a:endParaRPr lang="en-US" sz="1800" dirty="0"/>
+          </a:p>
+        </p:txBody>
+      </p:sp>
+      <p:sp>
+        <p:nvSpPr>
+          <p:cNvPr id="11" name="Text 9"/>
+          <p:cNvSpPr txBox="1"/>
+          <p:nvPr/>
+        </p:nvSpPr>
+        <p:spPr>
+          <a:xfrm>
+            <a:off x="1408176" y="4069080"/>
+            <a:ext cx="7223760" cy="777240"/>
+          </a:xfrm>
+          <a:prstGeom prst="rect">
+            <a:avLst/>
+          </a:prstGeom>
+          <a:noFill/>
+          <a:ln/>
+        </p:spPr>
+        <p:txBody>
+          <a:bodyPr wrap="square" lIns="0" tIns="0" rIns="0" bIns="0" rtlCol="0" anchor="t"/>
+          <a:lstStyle/>
+          <a:p>
+            <a:pPr indent="0" marL="0">
+              <a:buNone/>
+            </a:pPr>
+            <a:r>
+              <a:rPr lang="en-US" sz="1400" dirty="0">
+                <a:solidFill>
+                  <a:schemeClr val="tx2"/>
+                </a:solidFill>
+              </a:rPr>
+              <a:t>PAN, Aadhaar, mobile and trades stay in the learner’s private space. Facilitators see only names and progress.</a:t>
+            </a:r>
+            <a:endParaRPr lang="en-US" sz="1400" dirty="0"/>
+          </a:p>
+        </p:txBody>
+      </p:sp>
+      <p:sp>
+        <p:nvSpPr>
+          <p:cNvPr id="12" name="Still works offline marker"/>
+          <p:cNvSpPr/>
+          <p:nvPr/>
+        </p:nvSpPr>
+        <p:spPr>
+          <a:xfrm>
+            <a:off x="813816" y="4818888"/>
+            <a:ext cx="384048" cy="384048"/>
+          </a:xfrm>
+          <a:prstGeom prst="ellipse">
+            <a:avLst/>
+          </a:prstGeom>
+          <a:solidFill>
+            <a:schemeClr val="accent1"/>
+          </a:solidFill>
+          <a:ln/>
+        </p:spPr>
+      </p:sp>
+      <p:sp>
+        <p:nvSpPr>
+          <p:cNvPr id="13" name="Text 11"/>
+          <p:cNvSpPr txBox="1"/>
+          <p:nvPr/>
+        </p:nvSpPr>
+        <p:spPr>
+          <a:xfrm>
+            <a:off x="813816" y="4864608"/>
+            <a:ext cx="384048" cy="292608"/>
+          </a:xfrm>
+          <a:prstGeom prst="rect">
+            <a:avLst/>
+          </a:prstGeom>
+          <a:noFill/>
+          <a:ln/>
+        </p:spPr>
+        <p:txBody>
+          <a:bodyPr wrap="square" lIns="0" tIns="0" rIns="0" bIns="0" rtlCol="0" anchor="t"/>
+          <a:lstStyle/>
+          <a:p>
+            <a:pPr algn="ctr" indent="0" marL="0">
+              <a:buNone/>
+            </a:pPr>
+            <a:r>
+              <a:rPr lang="en-US" sz="1400" b="1" dirty="0">
+                <a:solidFill>
+                  <a:schemeClr val="bg1"/>
+                </a:solidFill>
+              </a:rPr>
+              <a:t>3</a:t>
+            </a:r>
+            <a:endParaRPr lang="en-US" sz="1400" dirty="0"/>
+          </a:p>
+        </p:txBody>
+      </p:sp>
+      <p:sp>
+        <p:nvSpPr>
+          <p:cNvPr id="14" name="Text 12"/>
+          <p:cNvSpPr txBox="1"/>
+          <p:nvPr/>
+        </p:nvSpPr>
+        <p:spPr>
+          <a:xfrm>
+            <a:off x="1408176" y="4800600"/>
+            <a:ext cx="7223760" cy="384048"/>
+          </a:xfrm>
+          <a:prstGeom prst="rect">
+            <a:avLst/>
+          </a:prstGeom>
+          <a:noFill/>
+          <a:ln/>
+        </p:spPr>
+        <p:txBody>
+          <a:bodyPr wrap="square" lIns="0" tIns="0" rIns="0" bIns="0" rtlCol="0" anchor="t"/>
+          <a:lstStyle/>
+          <a:p>
+            <a:pPr indent="0" marL="0">
+              <a:buNone/>
+            </a:pPr>
+            <a:r>
+              <a:rPr lang="en-US" sz="1800" b="1" dirty="0">
+                <a:solidFill>
+                  <a:schemeClr val="tx1"/>
+                </a:solidFill>
+              </a:rPr>
+              <a:t>Still works offline</a:t>
+            </a:r>
+            <a:endParaRPr lang="en-US" sz="1800" dirty="0"/>
+          </a:p>
+        </p:txBody>
+      </p:sp>
+      <p:sp>
+        <p:nvSpPr>
+          <p:cNvPr id="15" name="Text 13"/>
+          <p:cNvSpPr txBox="1"/>
+          <p:nvPr/>
+        </p:nvSpPr>
+        <p:spPr>
+          <a:xfrm>
+            <a:off x="1408176" y="5212080"/>
+            <a:ext cx="7223760" cy="777240"/>
+          </a:xfrm>
+          <a:prstGeom prst="rect">
+            <a:avLst/>
+          </a:prstGeom>
+          <a:noFill/>
+          <a:ln/>
+        </p:spPr>
+        <p:txBody>
+          <a:bodyPr wrap="square" lIns="0" tIns="0" rIns="0" bIns="0" rtlCol="0" anchor="t"/>
+          <a:lstStyle/>
+          <a:p>
+            <a:pPr indent="0" marL="0">
+              <a:buNone/>
+            </a:pPr>
+            <a:r>
+              <a:rPr lang="en-US" sz="1400" dirty="0">
+                <a:solidFill>
+                  <a:schemeClr val="tx2"/>
+                </a:solidFill>
+              </a:rPr>
+              <a:t>With no network the app keeps going on the phone and saves again when it can.</a:t>
+            </a:r>
+            <a:endParaRPr lang="en-US" sz="1400" dirty="0"/>
+          </a:p>
+        </p:txBody>
+      </p:sp>
+      <p:sp>
+        <p:nvSpPr>
+          <p:cNvPr id="16" name="Backup phone frame"/>
+          <p:cNvSpPr/>
+          <p:nvPr/>
+        </p:nvSpPr>
+        <p:spPr>
+          <a:xfrm>
+            <a:off x="9217152" y="896112"/>
+            <a:ext cx="2231136" cy="4334256"/>
+          </a:xfrm>
+          <a:prstGeom prst="roundRect">
+            <a:avLst>
+              <a:gd name="adj" fmla="val 11475"/>
+            </a:avLst>
+          </a:prstGeom>
+          <a:solidFill>
+            <a:srgbClr val="061615"/>
+          </a:solidFill>
+          <a:ln/>
+        </p:spPr>
       </p:sp>
       <p:pic>
         <p:nvPicPr>
-          <p:cNvPr id="6" name="Facilitator portal screenshot" descr="Facilitator portal showing a demo group’s learners, their steps, scam scores and nominee status">    </p:cNvPr>
+          <p:cNvPr id="17" name="Backup phone" descr="Profile screen showing Cloud backup saved to the learner’s claude.ai account and membership of the demo learning group">    </p:cNvPr>
           <p:cNvPicPr>
             <a:picLocks noChangeAspect="1"/>
           </p:cNvPicPr>
@@ -3643,80 +4044,19 @@
         </p:nvPicPr>
         <p:blipFill>
           <a:blip r:embed="rId1"/>
-          <a:stretch>
-            <a:fillRect/>
-          </a:stretch>
+          <a:srcRect l="0" r="0" t="0" b="0"/>
+          <a:stretch/>
         </p:blipFill>
         <p:spPr>
           <a:xfrm>
-            <a:off x="5715000" y="914400"/>
-            <a:ext cx="3063240" cy="4111191"/>
+            <a:off x="9281160" y="960120"/>
+            <a:ext cx="2103120" cy="4206240"/>
           </a:xfrm>
           <a:prstGeom prst="rect">
             <a:avLst/>
           </a:prstGeom>
         </p:spPr>
       </p:pic>
-      <p:pic>
-        <p:nvPicPr>
-          <p:cNvPr id="7" name="Insights screenshot" descr="Insights page with learning-journey and Scam Shield accuracy bars">    </p:cNvPr>
-          <p:cNvPicPr>
-            <a:picLocks noChangeAspect="1"/>
-          </p:cNvPicPr>
-          <p:nvPr/>
-        </p:nvPicPr>
-        <p:blipFill>
-          <a:blip r:embed="rId2"/>
-          <a:stretch>
-            <a:fillRect/>
-          </a:stretch>
-        </p:blipFill>
-        <p:spPr>
-          <a:xfrm>
-            <a:off x="8961120" y="1837139"/>
-            <a:ext cx="2416759" cy="2265712"/>
-          </a:xfrm>
-          <a:prstGeom prst="rect">
-            <a:avLst/>
-          </a:prstGeom>
-        </p:spPr>
-      </p:pic>
-      <p:sp>
-        <p:nvSpPr>
-          <p:cNvPr id="8" name="Text 4"/>
-          <p:cNvSpPr txBox="1"/>
-          <p:nvPr/>
-        </p:nvSpPr>
-        <p:spPr>
-          <a:xfrm>
-            <a:off x="813816" y="6035040"/>
-            <a:ext cx="7315200" cy="320040"/>
-          </a:xfrm>
-          <a:prstGeom prst="rect">
-            <a:avLst/>
-          </a:prstGeom>
-          <a:noFill/>
-          <a:ln/>
-        </p:spPr>
-        <p:txBody>
-          <a:bodyPr wrap="square" lIns="0" tIns="0" rIns="0" bIns="0" rtlCol="0" anchor="t"/>
-          <a:lstStyle/>
-          <a:p>
-            <a:pPr indent="0" marL="0">
-              <a:buNone/>
-            </a:pPr>
-            <a:r>
-              <a:rPr lang="en-US" sz="1200" dirty="0">
-                <a:solidFill>
-                  <a:schemeClr val="accent6"/>
-                </a:solidFill>
-              </a:rPr>
-              <a:t>Screens show the seeded demo group; no real learner data.</a:t>
-            </a:r>
-            <a:endParaRPr lang="en-US" sz="1200" dirty="0"/>
-          </a:p>
-        </p:txBody>
-      </p:sp>
       <p:sp>
         <p:nvSpPr>
           <p:cNvPr id="25" name="Slide Number Placeholder 0"/>
@@ -3747,7 +4087,7 @@
             <a:lvl1pPr>
               <a:defRPr sz="1000">
                 <a:solidFill>
-                  <a:schemeClr val="accent6"/>
+                  <a:schemeClr val="tx2"/>
                 </a:solidFill>
               </a:defRPr>
             </a:lvl1pPr>
@@ -3816,10 +4156,10 @@
             <a:r>
               <a:rPr lang="en-US" sz="1200" b="1" spc="200" kern="0" dirty="0">
                 <a:solidFill>
-                  <a:schemeClr val="accent1"/>
-                </a:solidFill>
-              </a:rPr>
-              <a:t>HOW IT IS BUILT</a:t>
+                  <a:schemeClr val="accent4"/>
+                </a:solidFill>
+              </a:rPr>
+              <a:t>BEYOND ONE PHONE</a:t>
             </a:r>
             <a:endParaRPr lang="en-US" sz="1200" dirty="0"/>
           </a:p>
@@ -3836,7 +4176,7 @@
         <p:spPr>
           <a:xfrm>
             <a:off x="813816" y="1051560"/>
-            <a:ext cx="10564063" cy="1097280"/>
+            <a:ext cx="4572000" cy="2286000"/>
           </a:xfrm>
           <a:prstGeom prst="rect">
             <a:avLst/>
@@ -3854,10 +4194,10 @@
             <a:r>
               <a:rPr lang="en-US" sz="3600" b="1" dirty="0">
                 <a:solidFill>
-                  <a:schemeClr val="tx1"/>
-                </a:solidFill>
-              </a:rPr>
-              <a:t>Offline on any phone; the server keeps it honest</a:t>
+                  <a:schemeClr val="bg2"/>
+                </a:solidFill>
+              </a:rPr>
+              <a:t>Facilitators see who is stuck. CDSL sees what confuses people.</a:t>
             </a:r>
             <a:endParaRPr lang="en-US" sz="3600" dirty="0"/>
           </a:p>
@@ -3865,30 +4205,50 @@
       </p:sp>
       <p:sp>
         <p:nvSpPr>
-          <p:cNvPr id="4" name="Phone app box"/>
-          <p:cNvSpPr/>
-          <p:nvPr/>
-        </p:nvSpPr>
-        <p:spPr>
-          <a:xfrm>
-            <a:off x="813816" y="2286000"/>
-            <a:ext cx="3155594" cy="1874520"/>
-          </a:xfrm>
-          <a:prstGeom prst="roundRect">
-            <a:avLst>
-              <a:gd name="adj" fmla="val 7805"/>
-            </a:avLst>
-          </a:prstGeom>
-          <a:solidFill>
-            <a:schemeClr val="bg1"/>
-          </a:solidFill>
-          <a:ln w="19050">
-            <a:solidFill>
-              <a:srgbClr val="0F766E"/>
-            </a:solidFill>
-            <a:prstDash val="solid"/>
-          </a:ln>
-        </p:spPr>
+          <p:cNvPr id="4" name="Text 2"/>
+          <p:cNvSpPr txBox="1"/>
+          <p:nvPr/>
+        </p:nvSpPr>
+        <p:spPr>
+          <a:xfrm>
+            <a:off x="813816" y="3566160"/>
+            <a:ext cx="4572000" cy="1097280"/>
+          </a:xfrm>
+          <a:prstGeom prst="rect">
+            <a:avLst/>
+          </a:prstGeom>
+          <a:noFill/>
+          <a:ln/>
+        </p:spPr>
+        <p:txBody>
+          <a:bodyPr wrap="square" lIns="0" tIns="0" rIns="0" bIns="0" rtlCol="0" anchor="t"/>
+          <a:lstStyle/>
+          <a:p>
+            <a:pPr indent="0" marL="0">
+              <a:buNone/>
+            </a:pPr>
+            <a:r>
+              <a:rPr lang="en-US" sz="1600" b="1" dirty="0">
+                <a:solidFill>
+                  <a:schemeClr val="accent2"/>
+                </a:solidFill>
+              </a:rPr>
+              <a:t>SHG leaders and NGO trainers </a:t>
+            </a:r>
+            <a:pPr indent="0" marL="0">
+              <a:buNone/>
+            </a:pPr>
+            <a:r>
+              <a:rPr lang="en-US" sz="1600" dirty="0">
+                <a:solidFill>
+                  <a:schemeClr val="accent6"/>
+                </a:solidFill>
+              </a:rPr>
+              <a:t>open the facilitator view inside the app, create a group and share a 6-letter code.</a:t>
+            </a:r>
+            <a:endParaRPr lang="en-US" sz="1600" dirty="0"/>
+          </a:p>
+        </p:txBody>
       </p:sp>
       <p:sp>
         <p:nvSpPr>
@@ -3898,496 +4258,102 @@
         </p:nvSpPr>
         <p:spPr>
           <a:xfrm>
-            <a:off x="1069848" y="2514600"/>
-            <a:ext cx="2643530" cy="411480"/>
-          </a:xfrm>
-          <a:prstGeom prst="rect">
-            <a:avLst/>
-          </a:prstGeom>
-          <a:noFill/>
-          <a:ln/>
-        </p:spPr>
-        <p:txBody>
-          <a:bodyPr wrap="square" lIns="0" tIns="0" rIns="0" bIns="0" rtlCol="0" anchor="t"/>
-          <a:lstStyle/>
-          <a:p>
-            <a:pPr indent="0" marL="0">
-              <a:buNone/>
-            </a:pPr>
-            <a:r>
-              <a:rPr lang="en-US" sz="1800" b="1" dirty="0">
-                <a:solidFill>
-                  <a:schemeClr val="tx1"/>
-                </a:solidFill>
-              </a:rPr>
-              <a:t>Phone app</a:t>
-            </a:r>
-            <a:endParaRPr lang="en-US" sz="1800" dirty="0"/>
-          </a:p>
-        </p:txBody>
-      </p:sp>
-      <p:sp>
-        <p:nvSpPr>
-          <p:cNvPr id="6" name="Text 4"/>
-          <p:cNvSpPr txBox="1"/>
-          <p:nvPr/>
-        </p:nvSpPr>
-        <p:spPr>
-          <a:xfrm>
-            <a:off x="1069848" y="2971800"/>
-            <a:ext cx="2643530" cy="1097280"/>
-          </a:xfrm>
-          <a:prstGeom prst="rect">
-            <a:avLst/>
-          </a:prstGeom>
-          <a:noFill/>
-          <a:ln/>
-        </p:spPr>
-        <p:txBody>
-          <a:bodyPr wrap="square" lIns="0" tIns="0" rIns="0" bIns="0" rtlCol="0" anchor="t"/>
-          <a:lstStyle/>
-          <a:p>
-            <a:pPr indent="0" marL="0">
-              <a:buNone/>
-            </a:pPr>
-            <a:r>
-              <a:rPr lang="en-US" sz="1300" dirty="0">
-                <a:solidFill>
-                  <a:schemeClr val="tx2"/>
-                </a:solidFill>
-              </a:rPr>
-              <a:t>One 218 KB HTML file. Runs offline, Hindi and English, progress saved on the phone.</a:t>
-            </a:r>
-            <a:endParaRPr lang="en-US" sz="1300" dirty="0"/>
-          </a:p>
-        </p:txBody>
-      </p:sp>
-      <p:sp>
-        <p:nvSpPr>
-          <p:cNvPr id="7" name="Arrow 1"/>
-          <p:cNvSpPr/>
-          <p:nvPr/>
-        </p:nvSpPr>
-        <p:spPr>
-          <a:xfrm>
-            <a:off x="4060850" y="3223260"/>
-            <a:ext cx="365760" cy="0"/>
-          </a:xfrm>
-          <a:prstGeom prst="line">
-            <a:avLst/>
-          </a:prstGeom>
-          <a:noFill/>
-          <a:ln w="31750">
-            <a:solidFill>
-              <a:schemeClr val="accent1"/>
-            </a:solidFill>
-            <a:prstDash val="solid"/>
-            <a:tailEnd type="triangle"/>
-          </a:ln>
-        </p:spPr>
-      </p:sp>
-      <p:sp>
-        <p:nvSpPr>
-          <p:cNvPr id="8" name="Pehla Kadam server box"/>
-          <p:cNvSpPr/>
-          <p:nvPr/>
-        </p:nvSpPr>
-        <p:spPr>
-          <a:xfrm>
-            <a:off x="4518050" y="2286000"/>
-            <a:ext cx="3155594" cy="1874520"/>
-          </a:xfrm>
-          <a:prstGeom prst="roundRect">
-            <a:avLst>
-              <a:gd name="adj" fmla="val 7805"/>
-            </a:avLst>
-          </a:prstGeom>
-          <a:solidFill>
-            <a:schemeClr val="bg1"/>
-          </a:solidFill>
-          <a:ln w="19050">
-            <a:solidFill>
-              <a:srgbClr val="0F766E"/>
-            </a:solidFill>
-            <a:prstDash val="solid"/>
-          </a:ln>
-        </p:spPr>
-      </p:sp>
-      <p:sp>
-        <p:nvSpPr>
-          <p:cNvPr id="9" name="Text 7"/>
-          <p:cNvSpPr txBox="1"/>
-          <p:nvPr/>
-        </p:nvSpPr>
-        <p:spPr>
-          <a:xfrm>
-            <a:off x="4774082" y="2514600"/>
-            <a:ext cx="2643530" cy="411480"/>
-          </a:xfrm>
-          <a:prstGeom prst="rect">
-            <a:avLst/>
-          </a:prstGeom>
-          <a:noFill/>
-          <a:ln/>
-        </p:spPr>
-        <p:txBody>
-          <a:bodyPr wrap="square" lIns="0" tIns="0" rIns="0" bIns="0" rtlCol="0" anchor="t"/>
-          <a:lstStyle/>
-          <a:p>
-            <a:pPr indent="0" marL="0">
-              <a:buNone/>
-            </a:pPr>
-            <a:r>
-              <a:rPr lang="en-US" sz="1800" b="1" dirty="0">
-                <a:solidFill>
-                  <a:schemeClr val="tx1"/>
-                </a:solidFill>
-              </a:rPr>
-              <a:t>Pehla Kadam server</a:t>
-            </a:r>
-            <a:endParaRPr lang="en-US" sz="1800" dirty="0"/>
-          </a:p>
-        </p:txBody>
-      </p:sp>
-      <p:sp>
-        <p:nvSpPr>
-          <p:cNvPr id="10" name="Text 8"/>
-          <p:cNvSpPr txBox="1"/>
-          <p:nvPr/>
-        </p:nvSpPr>
-        <p:spPr>
-          <a:xfrm>
-            <a:off x="4774082" y="2971800"/>
-            <a:ext cx="2643530" cy="1097280"/>
-          </a:xfrm>
-          <a:prstGeom prst="rect">
-            <a:avLst/>
-          </a:prstGeom>
-          <a:noFill/>
-          <a:ln/>
-        </p:spPr>
-        <p:txBody>
-          <a:bodyPr wrap="square" lIns="0" tIns="0" rIns="0" bIns="0" rtlCol="0" anchor="t"/>
-          <a:lstStyle/>
-          <a:p>
-            <a:pPr indent="0" marL="0">
-              <a:buNone/>
-            </a:pPr>
-            <a:r>
-              <a:rPr lang="en-US" sz="1300" dirty="0">
-                <a:solidFill>
-                  <a:schemeClr val="tx2"/>
-                </a:solidFill>
-              </a:rPr>
-              <a:t>Node.js and SQLite. Replays every synced trade against the same price engine and refuses anything that does not add up.</a:t>
-            </a:r>
-            <a:endParaRPr lang="en-US" sz="1300" dirty="0"/>
-          </a:p>
-        </p:txBody>
-      </p:sp>
-      <p:sp>
-        <p:nvSpPr>
-          <p:cNvPr id="11" name="Arrow 2"/>
-          <p:cNvSpPr/>
-          <p:nvPr/>
-        </p:nvSpPr>
-        <p:spPr>
-          <a:xfrm>
-            <a:off x="7765085" y="3223260"/>
-            <a:ext cx="365760" cy="0"/>
-          </a:xfrm>
-          <a:prstGeom prst="line">
-            <a:avLst/>
-          </a:prstGeom>
-          <a:noFill/>
-          <a:ln w="31750">
-            <a:solidFill>
-              <a:schemeClr val="accent1"/>
-            </a:solidFill>
-            <a:prstDash val="solid"/>
-            <a:tailEnd type="triangle"/>
-          </a:ln>
-        </p:spPr>
-      </p:sp>
-      <p:sp>
-        <p:nvSpPr>
-          <p:cNvPr id="12" name="Depository ledger box"/>
-          <p:cNvSpPr/>
-          <p:nvPr/>
-        </p:nvSpPr>
-        <p:spPr>
-          <a:xfrm>
-            <a:off x="8222285" y="2286000"/>
-            <a:ext cx="3155594" cy="1874520"/>
-          </a:xfrm>
-          <a:prstGeom prst="roundRect">
-            <a:avLst>
-              <a:gd name="adj" fmla="val 7805"/>
-            </a:avLst>
-          </a:prstGeom>
-          <a:solidFill>
-            <a:schemeClr val="accent5"/>
-          </a:solidFill>
-          <a:ln/>
-        </p:spPr>
-      </p:sp>
-      <p:sp>
-        <p:nvSpPr>
-          <p:cNvPr id="13" name="Text 11"/>
-          <p:cNvSpPr txBox="1"/>
-          <p:nvPr/>
-        </p:nvSpPr>
-        <p:spPr>
-          <a:xfrm>
-            <a:off x="8478317" y="2514600"/>
-            <a:ext cx="2643530" cy="411480"/>
-          </a:xfrm>
-          <a:prstGeom prst="rect">
-            <a:avLst/>
-          </a:prstGeom>
-          <a:noFill/>
-          <a:ln/>
-        </p:spPr>
-        <p:txBody>
-          <a:bodyPr wrap="square" lIns="0" tIns="0" rIns="0" bIns="0" rtlCol="0" anchor="t"/>
-          <a:lstStyle/>
-          <a:p>
-            <a:pPr indent="0" marL="0">
-              <a:buNone/>
-            </a:pPr>
-            <a:r>
-              <a:rPr lang="en-US" sz="1800" b="1" dirty="0">
-                <a:solidFill>
-                  <a:schemeClr val="tx1"/>
-                </a:solidFill>
-              </a:rPr>
-              <a:t>Depository ledger</a:t>
-            </a:r>
-            <a:endParaRPr lang="en-US" sz="1800" dirty="0"/>
-          </a:p>
-        </p:txBody>
-      </p:sp>
-      <p:sp>
-        <p:nvSpPr>
-          <p:cNvPr id="14" name="Text 12"/>
-          <p:cNvSpPr txBox="1"/>
-          <p:nvPr/>
-        </p:nvSpPr>
-        <p:spPr>
-          <a:xfrm>
-            <a:off x="8478317" y="2971800"/>
-            <a:ext cx="2643530" cy="1097280"/>
-          </a:xfrm>
-          <a:prstGeom prst="rect">
-            <a:avLst/>
-          </a:prstGeom>
-          <a:noFill/>
-          <a:ln/>
-        </p:spPr>
-        <p:txBody>
-          <a:bodyPr wrap="square" lIns="0" tIns="0" rIns="0" bIns="0" rtlCol="0" anchor="t"/>
-          <a:lstStyle/>
-          <a:p>
-            <a:pPr indent="0" marL="0">
-              <a:buNone/>
-            </a:pPr>
-            <a:r>
-              <a:rPr lang="en-US" sz="1300" dirty="0">
-                <a:solidFill>
-                  <a:schemeClr val="tx1"/>
-                </a:solidFill>
-              </a:rPr>
-              <a:t>Demat accounts, holdings, transactions, T+1 settlement queue, corporate-action entitlements, nominees, votes.</a:t>
-            </a:r>
-            <a:endParaRPr lang="en-US" sz="1300" dirty="0"/>
-          </a:p>
-        </p:txBody>
-      </p:sp>
-      <p:sp>
-        <p:nvSpPr>
-          <p:cNvPr id="15" name="Text 13"/>
-          <p:cNvSpPr txBox="1"/>
-          <p:nvPr/>
-        </p:nvSpPr>
-        <p:spPr>
-          <a:xfrm>
-            <a:off x="813816" y="4617720"/>
-            <a:ext cx="2435276" cy="914400"/>
-          </a:xfrm>
-          <a:prstGeom prst="rect">
-            <a:avLst/>
-          </a:prstGeom>
-          <a:noFill/>
-          <a:ln/>
-        </p:spPr>
-        <p:txBody>
-          <a:bodyPr wrap="square" lIns="0" tIns="0" rIns="0" bIns="0" rtlCol="0" anchor="t"/>
-          <a:lstStyle/>
-          <a:p>
-            <a:pPr indent="0" marL="0">
-              <a:buNone/>
-            </a:pPr>
-            <a:r>
-              <a:rPr lang="en-US" sz="1300" b="1" dirty="0">
-                <a:solidFill>
-                  <a:schemeClr val="tx1"/>
-                </a:solidFill>
-              </a:rPr>
-              <a:t>24 automated tests</a:t>
-            </a:r>
-            <a:pPr indent="0" marL="0">
-              <a:buNone/>
-            </a:pPr>
-            <a:r>
-              <a:rPr lang="en-US" sz="1300" dirty="0">
-                <a:solidFill>
-                  <a:schemeClr val="tx2"/>
-                </a:solidFill>
-              </a:rPr>
-              <a:t>, including a price-parity check against the app</a:t>
-            </a:r>
-            <a:endParaRPr lang="en-US" sz="1300" dirty="0"/>
-          </a:p>
-        </p:txBody>
-      </p:sp>
-      <p:sp>
-        <p:nvSpPr>
-          <p:cNvPr id="16" name="Text 14"/>
-          <p:cNvSpPr txBox="1"/>
-          <p:nvPr/>
-        </p:nvSpPr>
-        <p:spPr>
-          <a:xfrm>
-            <a:off x="3523412" y="4617720"/>
-            <a:ext cx="2435276" cy="914400"/>
-          </a:xfrm>
-          <a:prstGeom prst="rect">
-            <a:avLst/>
-          </a:prstGeom>
-          <a:noFill/>
-          <a:ln/>
-        </p:spPr>
-        <p:txBody>
-          <a:bodyPr wrap="square" lIns="0" tIns="0" rIns="0" bIns="0" rtlCol="0" anchor="t"/>
-          <a:lstStyle/>
-          <a:p>
-            <a:pPr indent="0" marL="0">
-              <a:buNone/>
-            </a:pPr>
-            <a:r>
-              <a:rPr lang="en-US" sz="1300" b="1" dirty="0">
-                <a:solidFill>
-                  <a:schemeClr val="tx1"/>
-                </a:solidFill>
-              </a:rPr>
-              <a:t>Backup and restore</a:t>
-            </a:r>
-            <a:pPr indent="0" marL="0">
-              <a:buNone/>
-            </a:pPr>
-            <a:r>
-              <a:rPr lang="en-US" sz="1300" dirty="0">
-                <a:solidFill>
-                  <a:schemeClr val="tx2"/>
-                </a:solidFill>
-              </a:rPr>
-              <a:t> across phones, with conflict handling</a:t>
-            </a:r>
-            <a:endParaRPr lang="en-US" sz="1300" dirty="0"/>
-          </a:p>
-        </p:txBody>
-      </p:sp>
-      <p:sp>
-        <p:nvSpPr>
-          <p:cNvPr id="17" name="Text 15"/>
-          <p:cNvSpPr txBox="1"/>
-          <p:nvPr/>
-        </p:nvSpPr>
-        <p:spPr>
-          <a:xfrm>
-            <a:off x="6233008" y="4617720"/>
-            <a:ext cx="2435276" cy="914400"/>
-          </a:xfrm>
-          <a:prstGeom prst="rect">
-            <a:avLst/>
-          </a:prstGeom>
-          <a:noFill/>
-          <a:ln/>
-        </p:spPr>
-        <p:txBody>
-          <a:bodyPr wrap="square" lIns="0" tIns="0" rIns="0" bIns="0" rtlCol="0" anchor="t"/>
-          <a:lstStyle/>
-          <a:p>
-            <a:pPr indent="0" marL="0">
-              <a:buNone/>
-            </a:pPr>
-            <a:r>
-              <a:rPr lang="en-US" sz="1300" b="1" dirty="0">
-                <a:solidFill>
-                  <a:schemeClr val="tx1"/>
-                </a:solidFill>
-              </a:rPr>
-              <a:t>PINs hashed</a:t>
-            </a:r>
-            <a:pPr indent="0" marL="0">
-              <a:buNone/>
-            </a:pPr>
-            <a:r>
-              <a:rPr lang="en-US" sz="1300" dirty="0">
-                <a:solidFill>
-                  <a:schemeClr val="tx2"/>
-                </a:solidFill>
-              </a:rPr>
-              <a:t>; facilitators see names and progress only</a:t>
-            </a:r>
-            <a:endParaRPr lang="en-US" sz="1300" dirty="0"/>
-          </a:p>
-        </p:txBody>
-      </p:sp>
-      <p:sp>
-        <p:nvSpPr>
-          <p:cNvPr id="18" name="Text 16"/>
-          <p:cNvSpPr txBox="1"/>
-          <p:nvPr/>
-        </p:nvSpPr>
-        <p:spPr>
-          <a:xfrm>
-            <a:off x="8942603" y="4617720"/>
-            <a:ext cx="2435276" cy="914400"/>
-          </a:xfrm>
-          <a:prstGeom prst="rect">
-            <a:avLst/>
-          </a:prstGeom>
-          <a:noFill/>
-          <a:ln/>
-        </p:spPr>
-        <p:txBody>
-          <a:bodyPr wrap="square" lIns="0" tIns="0" rIns="0" bIns="0" rtlCol="0" anchor="t"/>
-          <a:lstStyle/>
-          <a:p>
-            <a:pPr indent="0" marL="0">
-              <a:buNone/>
-            </a:pPr>
-            <a:r>
-              <a:rPr lang="en-US" sz="1300" b="1" dirty="0">
-                <a:solidFill>
-                  <a:schemeClr val="tx1"/>
-                </a:solidFill>
-              </a:rPr>
-              <a:t>Deploys free</a:t>
-            </a:r>
-            <a:pPr indent="0" marL="0">
-              <a:buNone/>
-            </a:pPr>
-            <a:r>
-              <a:rPr lang="en-US" sz="1300" dirty="0">
-                <a:solidFill>
-                  <a:schemeClr val="tx2"/>
-                </a:solidFill>
-              </a:rPr>
-              <a:t> on Render from one Dockerfile</a:t>
-            </a:r>
-            <a:endParaRPr lang="en-US" sz="1300" dirty="0"/>
+            <a:off x="813816" y="4800600"/>
+            <a:ext cx="4572000" cy="914400"/>
+          </a:xfrm>
+          <a:prstGeom prst="rect">
+            <a:avLst/>
+          </a:prstGeom>
+          <a:noFill/>
+          <a:ln/>
+        </p:spPr>
+        <p:txBody>
+          <a:bodyPr wrap="square" lIns="0" tIns="0" rIns="0" bIns="0" rtlCol="0" anchor="t"/>
+          <a:lstStyle/>
+          <a:p>
+            <a:pPr indent="0" marL="0">
+              <a:buNone/>
+            </a:pPr>
+            <a:r>
+              <a:rPr lang="en-US" sz="1600" b="1" dirty="0">
+                <a:solidFill>
+                  <a:schemeClr val="accent2"/>
+                </a:solidFill>
+              </a:rPr>
+              <a:t>Anonymous insights </a:t>
+            </a:r>
+            <a:pPr indent="0" marL="0">
+              <a:buNone/>
+            </a:pPr>
+            <a:r>
+              <a:rPr lang="en-US" sz="1600" dirty="0">
+                <a:solidFill>
+                  <a:schemeClr val="accent6"/>
+                </a:solidFill>
+              </a:rPr>
+              <a:t>show everyone which steps learners skip and which scams still fool them.</a:t>
+            </a:r>
+            <a:endParaRPr lang="en-US" sz="1600" dirty="0"/>
+          </a:p>
+        </p:txBody>
+      </p:sp>
+      <p:pic>
+        <p:nvPicPr>
+          <p:cNvPr id="6" name="Facilitator view screenshot" descr="In-app facilitator view for the demo group: group code, summary tiles and a table of learners with their steps, scam scores and nominee status">    </p:cNvPr>
+          <p:cNvPicPr>
+            <a:picLocks noChangeAspect="1"/>
+          </p:cNvPicPr>
+          <p:nvPr/>
+        </p:nvPicPr>
+        <p:blipFill>
+          <a:blip r:embed="rId1"/>
+          <a:stretch>
+            <a:fillRect/>
+          </a:stretch>
+        </p:blipFill>
+        <p:spPr>
+          <a:xfrm>
+            <a:off x="5715000" y="777240"/>
+            <a:ext cx="5662879" cy="5251864"/>
+          </a:xfrm>
+          <a:prstGeom prst="rect">
+            <a:avLst/>
+          </a:prstGeom>
+        </p:spPr>
+      </p:pic>
+      <p:sp>
+        <p:nvSpPr>
+          <p:cNvPr id="7" name="Text 4"/>
+          <p:cNvSpPr txBox="1"/>
+          <p:nvPr/>
+        </p:nvSpPr>
+        <p:spPr>
+          <a:xfrm>
+            <a:off x="813816" y="6035040"/>
+            <a:ext cx="4572000" cy="320040"/>
+          </a:xfrm>
+          <a:prstGeom prst="rect">
+            <a:avLst/>
+          </a:prstGeom>
+          <a:noFill/>
+          <a:ln/>
+        </p:spPr>
+        <p:txBody>
+          <a:bodyPr wrap="square" lIns="0" tIns="0" rIns="0" bIns="0" rtlCol="0" anchor="t"/>
+          <a:lstStyle/>
+          <a:p>
+            <a:pPr indent="0" marL="0">
+              <a:buNone/>
+            </a:pPr>
+            <a:r>
+              <a:rPr lang="en-US" sz="1200" dirty="0">
+                <a:solidFill>
+                  <a:schemeClr val="accent6"/>
+                </a:solidFill>
+              </a:rPr>
+              <a:t>Screen shows the seeded demo group; no real learner data.</a:t>
+            </a:r>
+            <a:endParaRPr lang="en-US" sz="1200" dirty="0"/>
           </a:p>
         </p:txBody>
       </p:sp>
@@ -4421,7 +4387,7 @@
             <a:lvl1pPr>
               <a:defRPr sz="1000">
                 <a:solidFill>
-                  <a:schemeClr val="tx2"/>
+                  <a:schemeClr val="accent6"/>
                 </a:solidFill>
               </a:defRPr>
             </a:lvl1pPr>
@@ -4493,7 +4459,7 @@
                   <a:schemeClr val="accent1"/>
                 </a:solidFill>
               </a:rPr>
-              <a:t>WHAT COMES NEXT</a:t>
+              <a:t>HOW IT IS BUILT</a:t>
             </a:r>
             <a:endParaRPr lang="en-US" sz="1200" dirty="0"/>
           </a:p>
@@ -4531,7 +4497,7 @@
                   <a:schemeClr val="tx1"/>
                 </a:solidFill>
               </a:rPr>
-              <a:t>From prototype to every town, with CDSL</a:t>
+              <a:t>Offline on any phone, with two ways to sync</a:t>
             </a:r>
             <a:endParaRPr lang="en-US" sz="3600" dirty="0"/>
           </a:p>
@@ -4539,24 +4505,29 @@
       </p:sp>
       <p:sp>
         <p:nvSpPr>
-          <p:cNvPr id="4" name="Run it with real groups card"/>
+          <p:cNvPr id="4" name="Phone app box"/>
           <p:cNvSpPr/>
           <p:nvPr/>
         </p:nvSpPr>
         <p:spPr>
           <a:xfrm>
-            <a:off x="813816" y="2286000"/>
-            <a:ext cx="3338474" cy="3017520"/>
+            <a:off x="813816" y="2148840"/>
+            <a:ext cx="3291840" cy="2286000"/>
           </a:xfrm>
           <a:prstGeom prst="roundRect">
             <a:avLst>
-              <a:gd name="adj" fmla="val 4848"/>
+              <a:gd name="adj" fmla="val 6400"/>
             </a:avLst>
           </a:prstGeom>
           <a:solidFill>
             <a:schemeClr val="bg1"/>
           </a:solidFill>
-          <a:ln/>
+          <a:ln w="19050">
+            <a:solidFill>
+              <a:srgbClr val="0F766E"/>
+            </a:solidFill>
+            <a:prstDash val="solid"/>
+          </a:ln>
         </p:spPr>
       </p:sp>
       <p:sp>
@@ -4567,31 +4538,31 @@
         </p:nvSpPr>
         <p:spPr>
           <a:xfrm>
-            <a:off x="1106424" y="2578608"/>
-            <a:ext cx="2753258" cy="320040"/>
-          </a:xfrm>
-          <a:prstGeom prst="rect">
-            <a:avLst/>
-          </a:prstGeom>
-          <a:noFill/>
-          <a:ln/>
-        </p:spPr>
-        <p:txBody>
-          <a:bodyPr wrap="square" lIns="0" tIns="0" rIns="0" bIns="0" rtlCol="0" anchor="t"/>
-          <a:lstStyle/>
-          <a:p>
-            <a:pPr indent="0" marL="0">
-              <a:buNone/>
-            </a:pPr>
-            <a:r>
-              <a:rPr lang="en-US" sz="1200" b="1" dirty="0">
-                <a:solidFill>
-                  <a:schemeClr val="accent1"/>
-                </a:solidFill>
-              </a:rPr>
-              <a:t>01 · Pilot</a:t>
-            </a:r>
-            <a:endParaRPr lang="en-US" sz="1200" dirty="0"/>
+            <a:off x="1069848" y="2404872"/>
+            <a:ext cx="2779776" cy="411480"/>
+          </a:xfrm>
+          <a:prstGeom prst="rect">
+            <a:avLst/>
+          </a:prstGeom>
+          <a:noFill/>
+          <a:ln/>
+        </p:spPr>
+        <p:txBody>
+          <a:bodyPr wrap="square" lIns="0" tIns="0" rIns="0" bIns="0" rtlCol="0" anchor="t"/>
+          <a:lstStyle/>
+          <a:p>
+            <a:pPr indent="0" marL="0">
+              <a:buNone/>
+            </a:pPr>
+            <a:r>
+              <a:rPr lang="en-US" sz="1800" b="1" dirty="0">
+                <a:solidFill>
+                  <a:schemeClr val="tx1"/>
+                </a:solidFill>
+              </a:rPr>
+              <a:t>Phone app</a:t>
+            </a:r>
+            <a:endParaRPr lang="en-US" sz="1800" dirty="0"/>
           </a:p>
         </p:txBody>
       </p:sp>
@@ -4603,255 +4574,248 @@
         </p:nvSpPr>
         <p:spPr>
           <a:xfrm>
-            <a:off x="1106424" y="2971800"/>
-            <a:ext cx="2753258" cy="868680"/>
-          </a:xfrm>
-          <a:prstGeom prst="rect">
-            <a:avLst/>
-          </a:prstGeom>
-          <a:noFill/>
-          <a:ln/>
-        </p:spPr>
-        <p:txBody>
-          <a:bodyPr wrap="square" lIns="0" tIns="0" rIns="0" bIns="0" rtlCol="0" anchor="t"/>
-          <a:lstStyle/>
-          <a:p>
-            <a:pPr indent="0" marL="0">
-              <a:buNone/>
-            </a:pPr>
-            <a:r>
-              <a:rPr lang="en-US" sz="2200" b="1" dirty="0">
-                <a:solidFill>
-                  <a:schemeClr val="tx1"/>
-                </a:solidFill>
-              </a:rPr>
-              <a:t>Run it with real groups</a:t>
-            </a:r>
-            <a:endParaRPr lang="en-US" sz="2200" dirty="0"/>
-          </a:p>
-        </p:txBody>
-      </p:sp>
-      <p:sp>
-        <p:nvSpPr>
-          <p:cNvPr id="7" name="Text 5"/>
-          <p:cNvSpPr txBox="1"/>
-          <p:nvPr/>
-        </p:nvSpPr>
-        <p:spPr>
-          <a:xfrm>
-            <a:off x="1106424" y="3886200"/>
-            <a:ext cx="2753258" cy="1280160"/>
-          </a:xfrm>
-          <a:prstGeom prst="rect">
-            <a:avLst/>
-          </a:prstGeom>
-          <a:noFill/>
-          <a:ln/>
-        </p:spPr>
-        <p:txBody>
-          <a:bodyPr wrap="square" lIns="0" tIns="0" rIns="0" bIns="0" rtlCol="0" anchor="t"/>
-          <a:lstStyle/>
-          <a:p>
-            <a:pPr indent="0" marL="0">
-              <a:buNone/>
-            </a:pPr>
-            <a:r>
-              <a:rPr lang="en-US" sz="1400" dirty="0">
+            <a:off x="1069848" y="2880360"/>
+            <a:ext cx="2779776" cy="1371600"/>
+          </a:xfrm>
+          <a:prstGeom prst="rect">
+            <a:avLst/>
+          </a:prstGeom>
+          <a:noFill/>
+          <a:ln/>
+        </p:spPr>
+        <p:txBody>
+          <a:bodyPr wrap="square" lIns="0" tIns="0" rIns="0" bIns="0" rtlCol="0" anchor="t"/>
+          <a:lstStyle/>
+          <a:p>
+            <a:pPr indent="0" marL="0">
+              <a:buNone/>
+            </a:pPr>
+            <a:r>
+              <a:rPr lang="en-US" sz="1300" dirty="0">
                 <a:solidFill>
                   <a:schemeClr val="tx2"/>
                 </a:solidFill>
               </a:rPr>
-              <a:t>[2–3] DPs and SHG networks in [districts]. Measure confidence before and after with a short quiz.</a:t>
-            </a:r>
-            <a:endParaRPr lang="en-US" sz="1400" dirty="0"/>
-          </a:p>
-        </p:txBody>
-      </p:sp>
-      <p:sp>
-        <p:nvSpPr>
-          <p:cNvPr id="8" name="Beyond Hindi and English card"/>
+              <a:t>One 239 KB HTML file. Runs offline in Hindi and English, with progress saved on the phone.</a:t>
+            </a:r>
+            <a:endParaRPr lang="en-US" sz="1300" dirty="0"/>
+          </a:p>
+        </p:txBody>
+      </p:sp>
+      <p:sp>
+        <p:nvSpPr>
+          <p:cNvPr id="7" name="Arrow"/>
           <p:cNvSpPr/>
           <p:nvPr/>
         </p:nvSpPr>
         <p:spPr>
           <a:xfrm>
-            <a:off x="4426610" y="2286000"/>
-            <a:ext cx="3338474" cy="3017520"/>
+            <a:off x="4197096" y="3291840"/>
+            <a:ext cx="365760" cy="0"/>
+          </a:xfrm>
+          <a:prstGeom prst="line">
+            <a:avLst/>
+          </a:prstGeom>
+          <a:noFill/>
+          <a:ln w="31750">
+            <a:solidFill>
+              <a:schemeClr val="accent1"/>
+            </a:solidFill>
+            <a:prstDash val="solid"/>
+            <a:tailEnd type="triangle"/>
+          </a:ln>
+        </p:spPr>
+      </p:sp>
+      <p:sp>
+        <p:nvSpPr>
+          <p:cNvPr id="8" name="Hosted on claude.ai box"/>
+          <p:cNvSpPr/>
+          <p:nvPr/>
+        </p:nvSpPr>
+        <p:spPr>
+          <a:xfrm>
+            <a:off x="4654296" y="2148840"/>
+            <a:ext cx="6723583" cy="1069848"/>
           </a:xfrm>
           <a:prstGeom prst="roundRect">
             <a:avLst>
-              <a:gd name="adj" fmla="val 4848"/>
+              <a:gd name="adj" fmla="val 13675"/>
+            </a:avLst>
+          </a:prstGeom>
+          <a:solidFill>
+            <a:schemeClr val="accent5"/>
+          </a:solidFill>
+          <a:ln/>
+        </p:spPr>
+      </p:sp>
+      <p:sp>
+        <p:nvSpPr>
+          <p:cNvPr id="9" name="Text 7"/>
+          <p:cNvSpPr txBox="1"/>
+          <p:nvPr/>
+        </p:nvSpPr>
+        <p:spPr>
+          <a:xfrm>
+            <a:off x="4928616" y="2313432"/>
+            <a:ext cx="6174943" cy="365760"/>
+          </a:xfrm>
+          <a:prstGeom prst="rect">
+            <a:avLst/>
+          </a:prstGeom>
+          <a:noFill/>
+          <a:ln/>
+        </p:spPr>
+        <p:txBody>
+          <a:bodyPr wrap="square" lIns="0" tIns="0" rIns="0" bIns="0" rtlCol="0" anchor="t"/>
+          <a:lstStyle/>
+          <a:p>
+            <a:pPr indent="0" marL="0">
+              <a:buNone/>
+            </a:pPr>
+            <a:r>
+              <a:rPr lang="en-US" sz="1800" b="1" dirty="0">
+                <a:solidFill>
+                  <a:schemeClr val="tx1"/>
+                </a:solidFill>
+              </a:rPr>
+              <a:t>Hosted on claude.ai</a:t>
+            </a:r>
+            <a:endParaRPr lang="en-US" sz="1800" dirty="0"/>
+          </a:p>
+        </p:txBody>
+      </p:sp>
+      <p:sp>
+        <p:nvSpPr>
+          <p:cNvPr id="10" name="Text 8"/>
+          <p:cNvSpPr txBox="1"/>
+          <p:nvPr/>
+        </p:nvSpPr>
+        <p:spPr>
+          <a:xfrm>
+            <a:off x="4928616" y="2697480"/>
+            <a:ext cx="6174943" cy="457200"/>
+          </a:xfrm>
+          <a:prstGeom prst="rect">
+            <a:avLst/>
+          </a:prstGeom>
+          <a:noFill/>
+          <a:ln/>
+        </p:spPr>
+        <p:txBody>
+          <a:bodyPr wrap="square" lIns="0" tIns="0" rIns="0" bIns="0" rtlCol="0" anchor="t"/>
+          <a:lstStyle/>
+          <a:p>
+            <a:pPr indent="0" marL="0">
+              <a:buNone/>
+            </a:pPr>
+            <a:r>
+              <a:rPr lang="en-US" sz="1300" dirty="0">
+                <a:solidFill>
+                  <a:schemeClr val="tx1"/>
+                </a:solidFill>
+              </a:rPr>
+              <a:t>Built-in database: automatic backup, groups and insights with nothing to deploy. For people in our organization.</a:t>
+            </a:r>
+            <a:endParaRPr lang="en-US" sz="1300" dirty="0"/>
+          </a:p>
+        </p:txBody>
+      </p:sp>
+      <p:sp>
+        <p:nvSpPr>
+          <p:cNvPr id="11" name="Our own server box"/>
+          <p:cNvSpPr/>
+          <p:nvPr/>
+        </p:nvSpPr>
+        <p:spPr>
+          <a:xfrm>
+            <a:off x="4654296" y="3364992"/>
+            <a:ext cx="6723583" cy="1069848"/>
+          </a:xfrm>
+          <a:prstGeom prst="roundRect">
+            <a:avLst>
+              <a:gd name="adj" fmla="val 13675"/>
             </a:avLst>
           </a:prstGeom>
           <a:solidFill>
             <a:schemeClr val="bg1"/>
           </a:solidFill>
-          <a:ln/>
-        </p:spPr>
-      </p:sp>
-      <p:sp>
-        <p:nvSpPr>
-          <p:cNvPr id="9" name="Text 7"/>
-          <p:cNvSpPr txBox="1"/>
-          <p:nvPr/>
-        </p:nvSpPr>
-        <p:spPr>
-          <a:xfrm>
-            <a:off x="4719218" y="2578608"/>
-            <a:ext cx="2753258" cy="320040"/>
-          </a:xfrm>
-          <a:prstGeom prst="rect">
-            <a:avLst/>
-          </a:prstGeom>
-          <a:noFill/>
-          <a:ln/>
-        </p:spPr>
-        <p:txBody>
-          <a:bodyPr wrap="square" lIns="0" tIns="0" rIns="0" bIns="0" rtlCol="0" anchor="t"/>
-          <a:lstStyle/>
-          <a:p>
-            <a:pPr indent="0" marL="0">
-              <a:buNone/>
-            </a:pPr>
-            <a:r>
-              <a:rPr lang="en-US" sz="1200" b="1" dirty="0">
-                <a:solidFill>
-                  <a:schemeClr val="accent1"/>
-                </a:solidFill>
-              </a:rPr>
-              <a:t>02 · Languages</a:t>
-            </a:r>
-            <a:endParaRPr lang="en-US" sz="1200" dirty="0"/>
-          </a:p>
-        </p:txBody>
-      </p:sp>
-      <p:sp>
-        <p:nvSpPr>
-          <p:cNvPr id="10" name="Text 8"/>
-          <p:cNvSpPr txBox="1"/>
-          <p:nvPr/>
-        </p:nvSpPr>
-        <p:spPr>
-          <a:xfrm>
-            <a:off x="4719218" y="2971800"/>
-            <a:ext cx="2753258" cy="868680"/>
-          </a:xfrm>
-          <a:prstGeom prst="rect">
-            <a:avLst/>
-          </a:prstGeom>
-          <a:noFill/>
-          <a:ln/>
-        </p:spPr>
-        <p:txBody>
-          <a:bodyPr wrap="square" lIns="0" tIns="0" rIns="0" bIns="0" rtlCol="0" anchor="t"/>
-          <a:lstStyle/>
-          <a:p>
-            <a:pPr indent="0" marL="0">
-              <a:buNone/>
-            </a:pPr>
-            <a:r>
-              <a:rPr lang="en-US" sz="2200" b="1" dirty="0">
+          <a:ln w="19050">
+            <a:solidFill>
+              <a:srgbClr val="0F766E"/>
+            </a:solidFill>
+            <a:prstDash val="solid"/>
+          </a:ln>
+        </p:spPr>
+      </p:sp>
+      <p:sp>
+        <p:nvSpPr>
+          <p:cNvPr id="12" name="Text 10"/>
+          <p:cNvSpPr txBox="1"/>
+          <p:nvPr/>
+        </p:nvSpPr>
+        <p:spPr>
+          <a:xfrm>
+            <a:off x="4928616" y="3529584"/>
+            <a:ext cx="6174943" cy="365760"/>
+          </a:xfrm>
+          <a:prstGeom prst="rect">
+            <a:avLst/>
+          </a:prstGeom>
+          <a:noFill/>
+          <a:ln/>
+        </p:spPr>
+        <p:txBody>
+          <a:bodyPr wrap="square" lIns="0" tIns="0" rIns="0" bIns="0" rtlCol="0" anchor="t"/>
+          <a:lstStyle/>
+          <a:p>
+            <a:pPr indent="0" marL="0">
+              <a:buNone/>
+            </a:pPr>
+            <a:r>
+              <a:rPr lang="en-US" sz="1800" b="1" dirty="0">
                 <a:solidFill>
                   <a:schemeClr val="tx1"/>
                 </a:solidFill>
               </a:rPr>
-              <a:t>Beyond Hindi and English</a:t>
-            </a:r>
-            <a:endParaRPr lang="en-US" sz="2200" dirty="0"/>
-          </a:p>
-        </p:txBody>
-      </p:sp>
-      <p:sp>
-        <p:nvSpPr>
-          <p:cNvPr id="11" name="Text 9"/>
-          <p:cNvSpPr txBox="1"/>
-          <p:nvPr/>
-        </p:nvSpPr>
-        <p:spPr>
-          <a:xfrm>
-            <a:off x="4719218" y="3886200"/>
-            <a:ext cx="2753258" cy="1280160"/>
-          </a:xfrm>
-          <a:prstGeom prst="rect">
-            <a:avLst/>
-          </a:prstGeom>
-          <a:noFill/>
-          <a:ln/>
-        </p:spPr>
-        <p:txBody>
-          <a:bodyPr wrap="square" lIns="0" tIns="0" rIns="0" bIns="0" rtlCol="0" anchor="t"/>
-          <a:lstStyle/>
-          <a:p>
-            <a:pPr indent="0" marL="0">
-              <a:buNone/>
-            </a:pPr>
-            <a:r>
-              <a:rPr lang="en-US" sz="1400" dirty="0">
+              <a:t>Our own server</a:t>
+            </a:r>
+            <a:endParaRPr lang="en-US" sz="1800" dirty="0"/>
+          </a:p>
+        </p:txBody>
+      </p:sp>
+      <p:sp>
+        <p:nvSpPr>
+          <p:cNvPr id="13" name="Text 11"/>
+          <p:cNvSpPr txBox="1"/>
+          <p:nvPr/>
+        </p:nvSpPr>
+        <p:spPr>
+          <a:xfrm>
+            <a:off x="4928616" y="3913632"/>
+            <a:ext cx="6174943" cy="457200"/>
+          </a:xfrm>
+          <a:prstGeom prst="rect">
+            <a:avLst/>
+          </a:prstGeom>
+          <a:noFill/>
+          <a:ln/>
+        </p:spPr>
+        <p:txBody>
+          <a:bodyPr wrap="square" lIns="0" tIns="0" rIns="0" bIns="0" rtlCol="0" anchor="t"/>
+          <a:lstStyle/>
+          <a:p>
+            <a:pPr indent="0" marL="0">
+              <a:buNone/>
+            </a:pPr>
+            <a:r>
+              <a:rPr lang="en-US" sz="1300" dirty="0">
                 <a:solidFill>
                   <a:schemeClr val="tx2"/>
                 </a:solidFill>
               </a:rPr>
-              <a:t>Marathi, Bengali, Tamil and more. Every string already lives in one translation file.</a:t>
-            </a:r>
-            <a:endParaRPr lang="en-US" sz="1400" dirty="0"/>
-          </a:p>
-        </p:txBody>
-      </p:sp>
-      <p:sp>
-        <p:nvSpPr>
-          <p:cNvPr id="12" name="Hand off to a real account card"/>
-          <p:cNvSpPr/>
-          <p:nvPr/>
-        </p:nvSpPr>
-        <p:spPr>
-          <a:xfrm>
-            <a:off x="8039405" y="2286000"/>
-            <a:ext cx="3338474" cy="3017520"/>
-          </a:xfrm>
-          <a:prstGeom prst="roundRect">
-            <a:avLst>
-              <a:gd name="adj" fmla="val 4848"/>
-            </a:avLst>
-          </a:prstGeom>
-          <a:solidFill>
-            <a:schemeClr val="bg1"/>
-          </a:solidFill>
-          <a:ln/>
-        </p:spPr>
-      </p:sp>
-      <p:sp>
-        <p:nvSpPr>
-          <p:cNvPr id="13" name="Text 11"/>
-          <p:cNvSpPr txBox="1"/>
-          <p:nvPr/>
-        </p:nvSpPr>
-        <p:spPr>
-          <a:xfrm>
-            <a:off x="8332013" y="2578608"/>
-            <a:ext cx="2753258" cy="320040"/>
-          </a:xfrm>
-          <a:prstGeom prst="rect">
-            <a:avLst/>
-          </a:prstGeom>
-          <a:noFill/>
-          <a:ln/>
-        </p:spPr>
-        <p:txBody>
-          <a:bodyPr wrap="square" lIns="0" tIns="0" rIns="0" bIns="0" rtlCol="0" anchor="t"/>
-          <a:lstStyle/>
-          <a:p>
-            <a:pPr indent="0" marL="0">
-              <a:buNone/>
-            </a:pPr>
-            <a:r>
-              <a:rPr lang="en-US" sz="1200" b="1" dirty="0">
-                <a:solidFill>
-                  <a:schemeClr val="accent1"/>
-                </a:solidFill>
-              </a:rPr>
-              <a:t>03 · First real step</a:t>
-            </a:r>
-            <a:endParaRPr lang="en-US" sz="1200" dirty="0"/>
+              <a:t>Node.js and SQLite on any public URL. Re-checks every trade against the price engine and keeps a full depository ledger.</a:t>
+            </a:r>
+            <a:endParaRPr lang="en-US" sz="1300" dirty="0"/>
           </a:p>
         </p:txBody>
       </p:sp>
@@ -4863,31 +4827,42 @@
         </p:nvSpPr>
         <p:spPr>
           <a:xfrm>
-            <a:off x="8332013" y="2971800"/>
-            <a:ext cx="2753258" cy="868680"/>
-          </a:xfrm>
-          <a:prstGeom prst="rect">
-            <a:avLst/>
-          </a:prstGeom>
-          <a:noFill/>
-          <a:ln/>
-        </p:spPr>
-        <p:txBody>
-          <a:bodyPr wrap="square" lIns="0" tIns="0" rIns="0" bIns="0" rtlCol="0" anchor="t"/>
-          <a:lstStyle/>
-          <a:p>
-            <a:pPr indent="0" marL="0">
-              <a:buNone/>
-            </a:pPr>
-            <a:r>
-              <a:rPr lang="en-US" sz="2200" b="1" dirty="0">
+            <a:off x="813816" y="4846320"/>
+            <a:ext cx="2435276" cy="914400"/>
+          </a:xfrm>
+          <a:prstGeom prst="rect">
+            <a:avLst/>
+          </a:prstGeom>
+          <a:noFill/>
+          <a:ln/>
+        </p:spPr>
+        <p:txBody>
+          <a:bodyPr wrap="square" lIns="0" tIns="0" rIns="0" bIns="0" rtlCol="0" anchor="t"/>
+          <a:lstStyle/>
+          <a:p>
+            <a:pPr indent="0" marL="0">
+              <a:buNone/>
+            </a:pPr>
+            <a:r>
+              <a:rPr lang="en-US" sz="1300" b="1" dirty="0">
                 <a:solidFill>
                   <a:schemeClr val="tx1"/>
                 </a:solidFill>
               </a:rPr>
-              <a:t>Hand off to a real account</a:t>
-            </a:r>
-            <a:endParaRPr lang="en-US" sz="2200" dirty="0"/>
+              <a:t>24 automated tests</a:t>
+            </a:r>
+            <a:pPr indent="0" marL="0">
+              <a:buNone/>
+            </a:pPr>
+            <a:r>
+              <a:rPr lang="en-US" sz="1300" dirty="0">
+                <a:solidFill>
+                  <a:schemeClr val="tx2"/>
+                </a:solidFill>
+              </a:rPr>
+              <a:t>, including a price-parity check against the app</a:t>
+            </a:r>
+            <a:endParaRPr lang="en-US" sz="1300" dirty="0"/>
           </a:p>
         </p:txBody>
       </p:sp>
@@ -4899,31 +4874,136 @@
         </p:nvSpPr>
         <p:spPr>
           <a:xfrm>
-            <a:off x="8332013" y="3886200"/>
-            <a:ext cx="2753258" cy="1280160"/>
-          </a:xfrm>
-          <a:prstGeom prst="rect">
-            <a:avLst/>
-          </a:prstGeom>
-          <a:noFill/>
-          <a:ln/>
-        </p:spPr>
-        <p:txBody>
-          <a:bodyPr wrap="square" lIns="0" tIns="0" rIns="0" bIns="0" rtlCol="0" anchor="t"/>
-          <a:lstStyle/>
-          <a:p>
-            <a:pPr indent="0" marL="0">
-              <a:buNone/>
-            </a:pPr>
-            <a:r>
-              <a:rPr lang="en-US" sz="1400" dirty="0">
+            <a:off x="3523412" y="4846320"/>
+            <a:ext cx="2435276" cy="914400"/>
+          </a:xfrm>
+          <a:prstGeom prst="rect">
+            <a:avLst/>
+          </a:prstGeom>
+          <a:noFill/>
+          <a:ln/>
+        </p:spPr>
+        <p:txBody>
+          <a:bodyPr wrap="square" lIns="0" tIns="0" rIns="0" bIns="0" rtlCol="0" anchor="t"/>
+          <a:lstStyle/>
+          <a:p>
+            <a:pPr indent="0" marL="0">
+              <a:buNone/>
+            </a:pPr>
+            <a:r>
+              <a:rPr lang="en-US" sz="1300" b="1" dirty="0">
+                <a:solidFill>
+                  <a:schemeClr val="tx1"/>
+                </a:solidFill>
+              </a:rPr>
+              <a:t>Backup and restore</a:t>
+            </a:r>
+            <a:pPr indent="0" marL="0">
+              <a:buNone/>
+            </a:pPr>
+            <a:r>
+              <a:rPr lang="en-US" sz="1300" dirty="0">
                 <a:solidFill>
                   <a:schemeClr val="tx2"/>
                 </a:solidFill>
               </a:rPr>
-              <a:t>A guided move from practice to opening a demat account with a DP, using CDSL’s own alert and statement formats.</a:t>
-            </a:r>
-            <a:endParaRPr lang="en-US" sz="1400" dirty="0"/>
+              <a:t> across phones, with conflict handling</a:t>
+            </a:r>
+            <a:endParaRPr lang="en-US" sz="1300" dirty="0"/>
+          </a:p>
+        </p:txBody>
+      </p:sp>
+      <p:sp>
+        <p:nvSpPr>
+          <p:cNvPr id="16" name="Text 14"/>
+          <p:cNvSpPr txBox="1"/>
+          <p:nvPr/>
+        </p:nvSpPr>
+        <p:spPr>
+          <a:xfrm>
+            <a:off x="6233008" y="4846320"/>
+            <a:ext cx="2435276" cy="914400"/>
+          </a:xfrm>
+          <a:prstGeom prst="rect">
+            <a:avLst/>
+          </a:prstGeom>
+          <a:noFill/>
+          <a:ln/>
+        </p:spPr>
+        <p:txBody>
+          <a:bodyPr wrap="square" lIns="0" tIns="0" rIns="0" bIns="0" rtlCol="0" anchor="t"/>
+          <a:lstStyle/>
+          <a:p>
+            <a:pPr indent="0" marL="0">
+              <a:buNone/>
+            </a:pPr>
+            <a:r>
+              <a:rPr lang="en-US" sz="1300" b="1" dirty="0">
+                <a:solidFill>
+                  <a:schemeClr val="tx1"/>
+                </a:solidFill>
+              </a:rPr>
+              <a:t>Access rules</a:t>
+            </a:r>
+            <a:pPr indent="0" marL="0">
+              <a:buNone/>
+            </a:pPr>
+            <a:r>
+              <a:rPr lang="en-US" sz="1300" dirty="0">
+                <a:solidFill>
+                  <a:schemeClr val="tx2"/>
+                </a:solidFill>
+              </a:rPr>
+              <a:t>: learners never see each other’s data</a:t>
+            </a:r>
+            <a:endParaRPr lang="en-US" sz="1300" dirty="0"/>
+          </a:p>
+        </p:txBody>
+      </p:sp>
+      <p:sp>
+        <p:nvSpPr>
+          <p:cNvPr id="17" name="Text 15"/>
+          <p:cNvSpPr txBox="1"/>
+          <p:nvPr/>
+        </p:nvSpPr>
+        <p:spPr>
+          <a:xfrm>
+            <a:off x="8942603" y="4846320"/>
+            <a:ext cx="2435276" cy="914400"/>
+          </a:xfrm>
+          <a:prstGeom prst="rect">
+            <a:avLst/>
+          </a:prstGeom>
+          <a:noFill/>
+          <a:ln/>
+        </p:spPr>
+        <p:txBody>
+          <a:bodyPr wrap="square" lIns="0" tIns="0" rIns="0" bIns="0" rtlCol="0" anchor="t"/>
+          <a:lstStyle/>
+          <a:p>
+            <a:pPr indent="0" marL="0">
+              <a:buNone/>
+            </a:pPr>
+            <a:r>
+              <a:rPr lang="en-US" sz="1300" b="1" dirty="0">
+                <a:solidFill>
+                  <a:schemeClr val="tx1"/>
+                </a:solidFill>
+              </a:rPr>
+              <a:t>Free to run</a:t>
+            </a:r>
+            <a:pPr indent="0" marL="0">
+              <a:buNone/>
+            </a:pPr>
+            <a:r>
+              <a:rPr lang="en-US" sz="1300" dirty="0">
+                <a:solidFill>
+                  <a:schemeClr val="tx2"/>
+                </a:solidFill>
+              </a:rPr>
+              <a:t> on claude.ai or Render’s free plan</a:t>
+            </a:r>
+            <a:endParaRPr lang="en-US" sz="1300" dirty="0"/>
           </a:p>
         </p:txBody>
       </p:sp>
@@ -5026,6 +5106,542 @@
             <a:r>
               <a:rPr lang="en-US" sz="1200" b="1" spc="200" kern="0" dirty="0">
                 <a:solidFill>
+                  <a:schemeClr val="accent1"/>
+                </a:solidFill>
+              </a:rPr>
+              <a:t>WHAT COMES NEXT</a:t>
+            </a:r>
+            <a:endParaRPr lang="en-US" sz="1200" dirty="0"/>
+          </a:p>
+        </p:txBody>
+      </p:sp>
+      <p:sp>
+        <p:nvSpPr>
+          <p:cNvPr id="3" name="Text 0"/>
+          <p:cNvSpPr/>
+          <p:nvPr>
+            <p:ph idx="101" type="title" hasCustomPrompt="1"/>
+          </p:nvPr>
+        </p:nvSpPr>
+        <p:spPr>
+          <a:xfrm>
+            <a:off x="813816" y="1051560"/>
+            <a:ext cx="10564063" cy="1097280"/>
+          </a:xfrm>
+          <a:prstGeom prst="rect">
+            <a:avLst/>
+          </a:prstGeom>
+          <a:noFill/>
+          <a:ln/>
+        </p:spPr>
+        <p:txBody>
+          <a:bodyPr wrap="square" lIns="0" tIns="0" rIns="0" bIns="0" rtlCol="0" anchor="t"/>
+          <a:lstStyle/>
+          <a:p>
+            <a:pPr algn="l" indent="0" marL="0">
+              <a:buNone/>
+            </a:pPr>
+            <a:r>
+              <a:rPr lang="en-US" sz="3600" b="1" dirty="0">
+                <a:solidFill>
+                  <a:schemeClr val="tx1"/>
+                </a:solidFill>
+              </a:rPr>
+              <a:t>From prototype to every town, with CDSL</a:t>
+            </a:r>
+            <a:endParaRPr lang="en-US" sz="3600" dirty="0"/>
+          </a:p>
+        </p:txBody>
+      </p:sp>
+      <p:sp>
+        <p:nvSpPr>
+          <p:cNvPr id="4" name="Run it with real groups card"/>
+          <p:cNvSpPr/>
+          <p:nvPr/>
+        </p:nvSpPr>
+        <p:spPr>
+          <a:xfrm>
+            <a:off x="813816" y="2286000"/>
+            <a:ext cx="3338474" cy="3017520"/>
+          </a:xfrm>
+          <a:prstGeom prst="roundRect">
+            <a:avLst>
+              <a:gd name="adj" fmla="val 4848"/>
+            </a:avLst>
+          </a:prstGeom>
+          <a:solidFill>
+            <a:schemeClr val="bg1"/>
+          </a:solidFill>
+          <a:ln/>
+        </p:spPr>
+      </p:sp>
+      <p:sp>
+        <p:nvSpPr>
+          <p:cNvPr id="5" name="Text 3"/>
+          <p:cNvSpPr txBox="1"/>
+          <p:nvPr/>
+        </p:nvSpPr>
+        <p:spPr>
+          <a:xfrm>
+            <a:off x="1106424" y="2578608"/>
+            <a:ext cx="2753258" cy="320040"/>
+          </a:xfrm>
+          <a:prstGeom prst="rect">
+            <a:avLst/>
+          </a:prstGeom>
+          <a:noFill/>
+          <a:ln/>
+        </p:spPr>
+        <p:txBody>
+          <a:bodyPr wrap="square" lIns="0" tIns="0" rIns="0" bIns="0" rtlCol="0" anchor="t"/>
+          <a:lstStyle/>
+          <a:p>
+            <a:pPr indent="0" marL="0">
+              <a:buNone/>
+            </a:pPr>
+            <a:r>
+              <a:rPr lang="en-US" sz="1200" b="1" dirty="0">
+                <a:solidFill>
+                  <a:schemeClr val="accent1"/>
+                </a:solidFill>
+              </a:rPr>
+              <a:t>01 · Pilot</a:t>
+            </a:r>
+            <a:endParaRPr lang="en-US" sz="1200" dirty="0"/>
+          </a:p>
+        </p:txBody>
+      </p:sp>
+      <p:sp>
+        <p:nvSpPr>
+          <p:cNvPr id="6" name="Text 4"/>
+          <p:cNvSpPr txBox="1"/>
+          <p:nvPr/>
+        </p:nvSpPr>
+        <p:spPr>
+          <a:xfrm>
+            <a:off x="1106424" y="2971800"/>
+            <a:ext cx="2753258" cy="868680"/>
+          </a:xfrm>
+          <a:prstGeom prst="rect">
+            <a:avLst/>
+          </a:prstGeom>
+          <a:noFill/>
+          <a:ln/>
+        </p:spPr>
+        <p:txBody>
+          <a:bodyPr wrap="square" lIns="0" tIns="0" rIns="0" bIns="0" rtlCol="0" anchor="t"/>
+          <a:lstStyle/>
+          <a:p>
+            <a:pPr indent="0" marL="0">
+              <a:buNone/>
+            </a:pPr>
+            <a:r>
+              <a:rPr lang="en-US" sz="2200" b="1" dirty="0">
+                <a:solidFill>
+                  <a:schemeClr val="tx1"/>
+                </a:solidFill>
+              </a:rPr>
+              <a:t>Run it with real groups</a:t>
+            </a:r>
+            <a:endParaRPr lang="en-US" sz="2200" dirty="0"/>
+          </a:p>
+        </p:txBody>
+      </p:sp>
+      <p:sp>
+        <p:nvSpPr>
+          <p:cNvPr id="7" name="Text 5"/>
+          <p:cNvSpPr txBox="1"/>
+          <p:nvPr/>
+        </p:nvSpPr>
+        <p:spPr>
+          <a:xfrm>
+            <a:off x="1106424" y="3886200"/>
+            <a:ext cx="2753258" cy="1280160"/>
+          </a:xfrm>
+          <a:prstGeom prst="rect">
+            <a:avLst/>
+          </a:prstGeom>
+          <a:noFill/>
+          <a:ln/>
+        </p:spPr>
+        <p:txBody>
+          <a:bodyPr wrap="square" lIns="0" tIns="0" rIns="0" bIns="0" rtlCol="0" anchor="t"/>
+          <a:lstStyle/>
+          <a:p>
+            <a:pPr indent="0" marL="0">
+              <a:buNone/>
+            </a:pPr>
+            <a:r>
+              <a:rPr lang="en-US" sz="1400" dirty="0">
+                <a:solidFill>
+                  <a:schemeClr val="tx2"/>
+                </a:solidFill>
+              </a:rPr>
+              <a:t>[2–3] DPs and SHG networks in [districts]. Measure confidence before and after with a short quiz.</a:t>
+            </a:r>
+            <a:endParaRPr lang="en-US" sz="1400" dirty="0"/>
+          </a:p>
+        </p:txBody>
+      </p:sp>
+      <p:sp>
+        <p:nvSpPr>
+          <p:cNvPr id="8" name="Beyond Hindi and English card"/>
+          <p:cNvSpPr/>
+          <p:nvPr/>
+        </p:nvSpPr>
+        <p:spPr>
+          <a:xfrm>
+            <a:off x="4426610" y="2286000"/>
+            <a:ext cx="3338474" cy="3017520"/>
+          </a:xfrm>
+          <a:prstGeom prst="roundRect">
+            <a:avLst>
+              <a:gd name="adj" fmla="val 4848"/>
+            </a:avLst>
+          </a:prstGeom>
+          <a:solidFill>
+            <a:schemeClr val="bg1"/>
+          </a:solidFill>
+          <a:ln/>
+        </p:spPr>
+      </p:sp>
+      <p:sp>
+        <p:nvSpPr>
+          <p:cNvPr id="9" name="Text 7"/>
+          <p:cNvSpPr txBox="1"/>
+          <p:nvPr/>
+        </p:nvSpPr>
+        <p:spPr>
+          <a:xfrm>
+            <a:off x="4719218" y="2578608"/>
+            <a:ext cx="2753258" cy="320040"/>
+          </a:xfrm>
+          <a:prstGeom prst="rect">
+            <a:avLst/>
+          </a:prstGeom>
+          <a:noFill/>
+          <a:ln/>
+        </p:spPr>
+        <p:txBody>
+          <a:bodyPr wrap="square" lIns="0" tIns="0" rIns="0" bIns="0" rtlCol="0" anchor="t"/>
+          <a:lstStyle/>
+          <a:p>
+            <a:pPr indent="0" marL="0">
+              <a:buNone/>
+            </a:pPr>
+            <a:r>
+              <a:rPr lang="en-US" sz="1200" b="1" dirty="0">
+                <a:solidFill>
+                  <a:schemeClr val="accent1"/>
+                </a:solidFill>
+              </a:rPr>
+              <a:t>02 · Languages</a:t>
+            </a:r>
+            <a:endParaRPr lang="en-US" sz="1200" dirty="0"/>
+          </a:p>
+        </p:txBody>
+      </p:sp>
+      <p:sp>
+        <p:nvSpPr>
+          <p:cNvPr id="10" name="Text 8"/>
+          <p:cNvSpPr txBox="1"/>
+          <p:nvPr/>
+        </p:nvSpPr>
+        <p:spPr>
+          <a:xfrm>
+            <a:off x="4719218" y="2971800"/>
+            <a:ext cx="2753258" cy="868680"/>
+          </a:xfrm>
+          <a:prstGeom prst="rect">
+            <a:avLst/>
+          </a:prstGeom>
+          <a:noFill/>
+          <a:ln/>
+        </p:spPr>
+        <p:txBody>
+          <a:bodyPr wrap="square" lIns="0" tIns="0" rIns="0" bIns="0" rtlCol="0" anchor="t"/>
+          <a:lstStyle/>
+          <a:p>
+            <a:pPr indent="0" marL="0">
+              <a:buNone/>
+            </a:pPr>
+            <a:r>
+              <a:rPr lang="en-US" sz="2200" b="1" dirty="0">
+                <a:solidFill>
+                  <a:schemeClr val="tx1"/>
+                </a:solidFill>
+              </a:rPr>
+              <a:t>Beyond Hindi and English</a:t>
+            </a:r>
+            <a:endParaRPr lang="en-US" sz="2200" dirty="0"/>
+          </a:p>
+        </p:txBody>
+      </p:sp>
+      <p:sp>
+        <p:nvSpPr>
+          <p:cNvPr id="11" name="Text 9"/>
+          <p:cNvSpPr txBox="1"/>
+          <p:nvPr/>
+        </p:nvSpPr>
+        <p:spPr>
+          <a:xfrm>
+            <a:off x="4719218" y="3886200"/>
+            <a:ext cx="2753258" cy="1280160"/>
+          </a:xfrm>
+          <a:prstGeom prst="rect">
+            <a:avLst/>
+          </a:prstGeom>
+          <a:noFill/>
+          <a:ln/>
+        </p:spPr>
+        <p:txBody>
+          <a:bodyPr wrap="square" lIns="0" tIns="0" rIns="0" bIns="0" rtlCol="0" anchor="t"/>
+          <a:lstStyle/>
+          <a:p>
+            <a:pPr indent="0" marL="0">
+              <a:buNone/>
+            </a:pPr>
+            <a:r>
+              <a:rPr lang="en-US" sz="1400" dirty="0">
+                <a:solidFill>
+                  <a:schemeClr val="tx2"/>
+                </a:solidFill>
+              </a:rPr>
+              <a:t>Marathi, Bengali, Tamil and more. Every string already lives in one translation file.</a:t>
+            </a:r>
+            <a:endParaRPr lang="en-US" sz="1400" dirty="0"/>
+          </a:p>
+        </p:txBody>
+      </p:sp>
+      <p:sp>
+        <p:nvSpPr>
+          <p:cNvPr id="12" name="Hand off to a real account card"/>
+          <p:cNvSpPr/>
+          <p:nvPr/>
+        </p:nvSpPr>
+        <p:spPr>
+          <a:xfrm>
+            <a:off x="8039405" y="2286000"/>
+            <a:ext cx="3338474" cy="3017520"/>
+          </a:xfrm>
+          <a:prstGeom prst="roundRect">
+            <a:avLst>
+              <a:gd name="adj" fmla="val 4848"/>
+            </a:avLst>
+          </a:prstGeom>
+          <a:solidFill>
+            <a:schemeClr val="bg1"/>
+          </a:solidFill>
+          <a:ln/>
+        </p:spPr>
+      </p:sp>
+      <p:sp>
+        <p:nvSpPr>
+          <p:cNvPr id="13" name="Text 11"/>
+          <p:cNvSpPr txBox="1"/>
+          <p:nvPr/>
+        </p:nvSpPr>
+        <p:spPr>
+          <a:xfrm>
+            <a:off x="8332013" y="2578608"/>
+            <a:ext cx="2753258" cy="320040"/>
+          </a:xfrm>
+          <a:prstGeom prst="rect">
+            <a:avLst/>
+          </a:prstGeom>
+          <a:noFill/>
+          <a:ln/>
+        </p:spPr>
+        <p:txBody>
+          <a:bodyPr wrap="square" lIns="0" tIns="0" rIns="0" bIns="0" rtlCol="0" anchor="t"/>
+          <a:lstStyle/>
+          <a:p>
+            <a:pPr indent="0" marL="0">
+              <a:buNone/>
+            </a:pPr>
+            <a:r>
+              <a:rPr lang="en-US" sz="1200" b="1" dirty="0">
+                <a:solidFill>
+                  <a:schemeClr val="accent1"/>
+                </a:solidFill>
+              </a:rPr>
+              <a:t>03 · First real step</a:t>
+            </a:r>
+            <a:endParaRPr lang="en-US" sz="1200" dirty="0"/>
+          </a:p>
+        </p:txBody>
+      </p:sp>
+      <p:sp>
+        <p:nvSpPr>
+          <p:cNvPr id="14" name="Text 12"/>
+          <p:cNvSpPr txBox="1"/>
+          <p:nvPr/>
+        </p:nvSpPr>
+        <p:spPr>
+          <a:xfrm>
+            <a:off x="8332013" y="2971800"/>
+            <a:ext cx="2753258" cy="868680"/>
+          </a:xfrm>
+          <a:prstGeom prst="rect">
+            <a:avLst/>
+          </a:prstGeom>
+          <a:noFill/>
+          <a:ln/>
+        </p:spPr>
+        <p:txBody>
+          <a:bodyPr wrap="square" lIns="0" tIns="0" rIns="0" bIns="0" rtlCol="0" anchor="t"/>
+          <a:lstStyle/>
+          <a:p>
+            <a:pPr indent="0" marL="0">
+              <a:buNone/>
+            </a:pPr>
+            <a:r>
+              <a:rPr lang="en-US" sz="2200" b="1" dirty="0">
+                <a:solidFill>
+                  <a:schemeClr val="tx1"/>
+                </a:solidFill>
+              </a:rPr>
+              <a:t>Hand off to a real account</a:t>
+            </a:r>
+            <a:endParaRPr lang="en-US" sz="2200" dirty="0"/>
+          </a:p>
+        </p:txBody>
+      </p:sp>
+      <p:sp>
+        <p:nvSpPr>
+          <p:cNvPr id="15" name="Text 13"/>
+          <p:cNvSpPr txBox="1"/>
+          <p:nvPr/>
+        </p:nvSpPr>
+        <p:spPr>
+          <a:xfrm>
+            <a:off x="8332013" y="3886200"/>
+            <a:ext cx="2753258" cy="1280160"/>
+          </a:xfrm>
+          <a:prstGeom prst="rect">
+            <a:avLst/>
+          </a:prstGeom>
+          <a:noFill/>
+          <a:ln/>
+        </p:spPr>
+        <p:txBody>
+          <a:bodyPr wrap="square" lIns="0" tIns="0" rIns="0" bIns="0" rtlCol="0" anchor="t"/>
+          <a:lstStyle/>
+          <a:p>
+            <a:pPr indent="0" marL="0">
+              <a:buNone/>
+            </a:pPr>
+            <a:r>
+              <a:rPr lang="en-US" sz="1400" dirty="0">
+                <a:solidFill>
+                  <a:schemeClr val="tx2"/>
+                </a:solidFill>
+              </a:rPr>
+              <a:t>A guided move from practice to opening a demat account with a DP, using CDSL’s own alert and statement formats.</a:t>
+            </a:r>
+            <a:endParaRPr lang="en-US" sz="1400" dirty="0"/>
+          </a:p>
+        </p:txBody>
+      </p:sp>
+      <p:sp>
+        <p:nvSpPr>
+          <p:cNvPr id="25" name="Slide Number Placeholder 0"/>
+          <p:cNvSpPr>
+            <a:spLocks noGrp="1"/>
+          </p:cNvSpPr>
+          <p:nvPr>
+            <p:ph type="sldNum" sz="quarter" idx="4294967295"/>
+          </p:nvPr>
+        </p:nvSpPr>
+        <p:spPr>
+          <a:xfrm>
+            <a:off x="10972800" y="6355080"/>
+            <a:ext cx="457200" cy="274320"/>
+          </a:xfrm>
+          <a:prstGeom prst="rect">
+            <a:avLst/>
+          </a:prstGeom>
+          <a:extLst>
+            <a:ext uri="{C572A759-6A51-4108-AA02-DFA0A04FC94B}">
+              <ma14:wrappingTextBoxFlag xmlns:ma14="http://schemas.microsoft.com/office/mac/drawingml/2011/main" val="0"/>
+            </a:ext>
+          </a:extLst>
+        </p:spPr>
+        <p:txBody>
+          <a:bodyPr/>
+          <a:lstStyle>
+            <a:lvl1pPr>
+              <a:defRPr sz="1000">
+                <a:solidFill>
+                  <a:schemeClr val="tx2"/>
+                </a:solidFill>
+              </a:defRPr>
+            </a:lvl1pPr>
+          </a:lstStyle>
+          <a:p>
+            <a:pPr algn="r"/>
+            <a:fld id="{F7021451-1387-4CA6-816F-3879F97B5CBC}" type="slidenum">
+              <a:rPr b="0" lang="en-US"/>
+              <a:t>13</a:t>
+            </a:fld>
+            <a:endParaRPr lang="en-US"/>
+          </a:p>
+        </p:txBody>
+      </p:sp>
+    </p:spTree>
+  </p:cSld>
+  <p:clrMapOvr>
+    <a:masterClrMapping/>
+  </p:clrMapOvr>
+</p:sld>
+</file>
+
+<file path=ppt/slides/slide14.xml><?xml version="1.0" encoding="utf-8"?>
+<p:sld xmlns:a="http://schemas.openxmlformats.org/drawingml/2006/main" xmlns:r="http://schemas.openxmlformats.org/officeDocument/2006/relationships" xmlns:p="http://schemas.openxmlformats.org/presentationml/2006/main">
+  <p:cSld name="Slide 14">
+    <p:spTree>
+      <p:nvGrpSpPr>
+        <p:cNvPr id="1" name=""/>
+        <p:cNvGrpSpPr/>
+        <p:nvPr/>
+      </p:nvGrpSpPr>
+      <p:grpSpPr>
+        <a:xfrm>
+          <a:off x="0" y="0"/>
+          <a:ext cx="0" cy="0"/>
+          <a:chOff x="0" y="0"/>
+          <a:chExt cx="0" cy="0"/>
+        </a:xfrm>
+      </p:grpSpPr>
+      <p:sp>
+        <p:nvSpPr>
+          <p:cNvPr id="2" name="Text 0"/>
+          <p:cNvSpPr/>
+          <p:nvPr>
+            <p:ph idx="100" type="body" hasCustomPrompt="1"/>
+          </p:nvPr>
+        </p:nvSpPr>
+        <p:spPr>
+          <a:xfrm>
+            <a:off x="813816" y="658368"/>
+            <a:ext cx="10564063" cy="347472"/>
+          </a:xfrm>
+          <a:prstGeom prst="rect">
+            <a:avLst/>
+          </a:prstGeom>
+          <a:noFill/>
+          <a:ln/>
+        </p:spPr>
+        <p:txBody>
+          <a:bodyPr wrap="square" lIns="0" tIns="0" rIns="0" bIns="0" rtlCol="0" anchor="t"/>
+          <a:lstStyle/>
+          <a:p>
+            <a:pPr indent="0" marL="0">
+              <a:buNone/>
+            </a:pPr>
+            <a:r>
+              <a:rPr lang="en-US" sz="1200" b="1" spc="200" kern="0" dirty="0">
+                <a:solidFill>
                   <a:schemeClr val="accent4"/>
                 </a:solidFill>
               </a:rPr>
@@ -5548,7 +6164,7 @@
             <a:pPr algn="r"/>
             <a:fld id="{F7021451-1387-4CA6-816F-3879F97B5CBC}" type="slidenum">
               <a:rPr b="0" lang="en-US"/>
-              <a:t>13</a:t>
+              <a:t>14</a:t>
             </a:fld>
             <a:endParaRPr lang="en-US"/>
           </a:p>
@@ -6507,9 +7123,8 @@
         </p:nvPicPr>
         <p:blipFill>
           <a:blip r:embed="rId1"/>
-          <a:stretch>
-            <a:fillRect/>
-          </a:stretch>
+          <a:srcRect l="0" r="0" t="0" b="0"/>
+          <a:stretch/>
         </p:blipFill>
         <p:spPr>
           <a:xfrm>
@@ -8999,9 +9614,8 @@
         </p:nvPicPr>
         <p:blipFill>
           <a:blip r:embed="rId1"/>
-          <a:stretch>
-            <a:fillRect/>
-          </a:stretch>
+          <a:srcRect l="0" r="0" t="0" b="0"/>
+          <a:stretch/>
         </p:blipFill>
         <p:spPr>
           <a:xfrm>
@@ -9095,9 +9709,8 @@
         </p:nvPicPr>
         <p:blipFill>
           <a:blip r:embed="rId2"/>
-          <a:stretch>
-            <a:fillRect/>
-          </a:stretch>
+          <a:srcRect l="0" r="0" t="0" b="0"/>
+          <a:stretch/>
         </p:blipFill>
         <p:spPr>
           <a:xfrm>
@@ -9191,9 +9804,8 @@
         </p:nvPicPr>
         <p:blipFill>
           <a:blip r:embed="rId3"/>
-          <a:stretch>
-            <a:fillRect/>
-          </a:stretch>
+          <a:srcRect l="0" r="0" t="0" b="0"/>
+          <a:stretch/>
         </p:blipFill>
         <p:spPr>
           <a:xfrm>
@@ -9287,9 +9899,8 @@
         </p:nvPicPr>
         <p:blipFill>
           <a:blip r:embed="rId4"/>
-          <a:stretch>
-            <a:fillRect/>
-          </a:stretch>
+          <a:srcRect l="0" r="0" t="0" b="0"/>
+          <a:stretch/>
         </p:blipFill>
         <p:spPr>
           <a:xfrm>
@@ -9913,9 +10524,8 @@
         </p:nvPicPr>
         <p:blipFill>
           <a:blip r:embed="rId1"/>
-          <a:stretch>
-            <a:fillRect/>
-          </a:stretch>
+          <a:srcRect l="0" r="0" t="0" b="0"/>
+          <a:stretch/>
         </p:blipFill>
         <p:spPr>
           <a:xfrm>

</xml_diff>

<commit_message>
Add the live Render URL to the pitch deck and README
Co-Authored-By: Claude Opus 5.5 <noreply@anthropic.com>
Claude-Session: https://claude.ai/code/session_017mVkYdAtUcUqUrgRiSXn8W
</commit_message>
<xml_diff>
--- a/pitch/Pehla Kadam - pitch.pptx
+++ b/pitch/Pehla Kadam - pitch.pptx
@@ -120,21 +120,21 @@
   <p:extLst>
     <p:ext uri="{521415D9-36F7-43E2-AB2F-B90AF26B5E84}">
       <p14:sectionLst xmlns:p14="http://schemas.microsoft.com/office/powerpoint/2010/main">
-        <p14:section name="Why" id="{49f9bdd5-7a51-d699-0243-82d0526d0fb4}">
+        <p14:section name="Why" id="{a81d53c7-c20b-bbd7-0184-798cc8e126a1}">
           <p14:sldIdLst>
             <p14:sldId id="256"/>
             <p14:sldId id="257"/>
             <p14:sldId id="258"/>
           </p14:sldIdLst>
         </p14:section>
-        <p14:section name="The idea" id="{e4aaf83a-6ef7-512c-8299-7ef7b484a8e8}">
+        <p14:section name="The idea" id="{9146fed4-7ed0-5dd6-81bc-c15f967f8a40}">
           <p14:sldIdLst>
             <p14:sldId id="259"/>
             <p14:sldId id="260"/>
             <p14:sldId id="261"/>
           </p14:sldIdLst>
         </p14:section>
-        <p14:section name="The product" id="{effc4795-b051-8af6-02db-eb3e30912d47}">
+        <p14:section name="The product" id="{1c1f7c2f-89d6-30dd-9b0d-a3178a83dfe6}">
           <p14:sldIdLst>
             <p14:sldId id="262"/>
             <p14:sldId id="263"/>
@@ -143,7 +143,7 @@
             <p14:sldId id="266"/>
           </p14:sldIdLst>
         </p14:section>
-        <p14:section name="Build and next steps" id="{75445ae2-16d9-cfd4-9d76-4b88c5015ca9}">
+        <p14:section name="Build and next steps" id="{8dca606f-288a-5a84-4b73-7d1783872481}">
           <p14:sldIdLst>
             <p14:sldId id="267"/>
             <p14:sldId id="268"/>
@@ -994,7 +994,7 @@
           <a:p>
             <a:r>
               <a:rPr lang="en-US" dirty="0"/>
-              <a:t>Please try it yourselves: it takes about three minutes. Open an account with demo details, buy some ITC on day one, tap “Next day” and watch the CDSL alert and then the dividend arrive. Open the CAS statement and the dashboard, and try Scam Shield. Pehla Kadam is the first step to becoming an Atmanirbhar investor. Thank you.</a:t>
+              <a:t>Please try it yourselves: it takes about three minutes. Open an account with demo details, buy some ITC on day one, tap “Next day” and watch the CDSL alert and then the dividend arrive. Open the CAS statement and the dashboard, and try Scam Shield. The live demo is at cdsl-qnzc.onrender.com; on its free plan the first visit after a quiet spell can take up to a minute while it wakes up. Pehla Kadam is the first step to becoming an Atmanirbhar investor. Thank you.</a:t>
             </a:r>
             <a:endParaRPr lang="en-US" dirty="0"/>
           </a:p>
@@ -6019,12 +6019,19 @@
               <a:buNone/>
             </a:pPr>
             <a:r>
-              <a:rPr lang="en-US" sz="1600" b="1" dirty="0">
+              <a:rPr lang="en-US" sz="1600" b="1" u="sng" dirty="0">
                 <a:solidFill>
                   <a:schemeClr val="bg2"/>
                 </a:solidFill>
-              </a:rPr>
-              <a:t>[Render URL]</a:t>
+                <a:hlinkClick r:id="rId1" invalidUrl="" action="" tgtFrame="" tooltip="" history="1" highlightClick="0" endSnd="0">
+                  <a:extLst>
+                    <a:ext uri="{A12FA001-AC4F-418D-AE19-62706E023703}">
+                      <ahyp:hlinkClr xmlns:ahyp="http://schemas.microsoft.com/office/drawing/2018/hyperlinkcolor" val="tx"/>
+                    </a:ext>
+                  </a:extLst>
+                </a:hlinkClick>
+              </a:rPr>
+              <a:t>cdsl-qnzc.onrender.com</a:t>
             </a:r>
             <a:pPr indent="0" marL="0">
               <a:buNone/>
@@ -6045,7 +6052,7 @@
                 <a:solidFill>
                   <a:schemeClr val="bg2"/>
                 </a:solidFill>
-                <a:hlinkClick r:id="rId1" invalidUrl="" action="" tgtFrame="" tooltip="" history="1" highlightClick="0" endSnd="0">
+                <a:hlinkClick r:id="rId2" invalidUrl="" action="" tgtFrame="" tooltip="" history="1" highlightClick="0" endSnd="0">
                   <a:extLst>
                     <a:ext uri="{A12FA001-AC4F-418D-AE19-62706E023703}">
                       <ahyp:hlinkClr xmlns:ahyp="http://schemas.microsoft.com/office/drawing/2018/hyperlinkcolor" val="tx"/>

</xml_diff>